<commit_message>
5/7 Commit 2: Works
</commit_message>
<xml_diff>
--- a/RISCVstage4.pptx
+++ b/RISCVstage4.pptx
@@ -464,7 +464,7 @@
           <a:p>
             <a:fld id="{51AFF834-1BEC-4F95-9622-28B5DCC1FE16}" type="datetimeFigureOut">
               <a:rPr lang="en-US" smtClean="0"/>
-              <a:t>4/18/2026</a:t>
+              <a:t>5/7/2026</a:t>
             </a:fld>
             <a:endParaRPr lang="en-US"/>
           </a:p>
@@ -662,7 +662,7 @@
           <a:p>
             <a:fld id="{51AFF834-1BEC-4F95-9622-28B5DCC1FE16}" type="datetimeFigureOut">
               <a:rPr lang="en-US" smtClean="0"/>
-              <a:t>4/18/2026</a:t>
+              <a:t>5/7/2026</a:t>
             </a:fld>
             <a:endParaRPr lang="en-US"/>
           </a:p>
@@ -870,7 +870,7 @@
           <a:p>
             <a:fld id="{51AFF834-1BEC-4F95-9622-28B5DCC1FE16}" type="datetimeFigureOut">
               <a:rPr lang="en-US" smtClean="0"/>
-              <a:t>4/18/2026</a:t>
+              <a:t>5/7/2026</a:t>
             </a:fld>
             <a:endParaRPr lang="en-US"/>
           </a:p>
@@ -1068,7 +1068,7 @@
           <a:p>
             <a:fld id="{51AFF834-1BEC-4F95-9622-28B5DCC1FE16}" type="datetimeFigureOut">
               <a:rPr lang="en-US" smtClean="0"/>
-              <a:t>4/18/2026</a:t>
+              <a:t>5/7/2026</a:t>
             </a:fld>
             <a:endParaRPr lang="en-US"/>
           </a:p>
@@ -1343,7 +1343,7 @@
           <a:p>
             <a:fld id="{51AFF834-1BEC-4F95-9622-28B5DCC1FE16}" type="datetimeFigureOut">
               <a:rPr lang="en-US" smtClean="0"/>
-              <a:t>4/18/2026</a:t>
+              <a:t>5/7/2026</a:t>
             </a:fld>
             <a:endParaRPr lang="en-US"/>
           </a:p>
@@ -1608,7 +1608,7 @@
           <a:p>
             <a:fld id="{51AFF834-1BEC-4F95-9622-28B5DCC1FE16}" type="datetimeFigureOut">
               <a:rPr lang="en-US" smtClean="0"/>
-              <a:t>4/18/2026</a:t>
+              <a:t>5/7/2026</a:t>
             </a:fld>
             <a:endParaRPr lang="en-US"/>
           </a:p>
@@ -2020,7 +2020,7 @@
           <a:p>
             <a:fld id="{51AFF834-1BEC-4F95-9622-28B5DCC1FE16}" type="datetimeFigureOut">
               <a:rPr lang="en-US" smtClean="0"/>
-              <a:t>4/18/2026</a:t>
+              <a:t>5/7/2026</a:t>
             </a:fld>
             <a:endParaRPr lang="en-US"/>
           </a:p>
@@ -2161,7 +2161,7 @@
           <a:p>
             <a:fld id="{51AFF834-1BEC-4F95-9622-28B5DCC1FE16}" type="datetimeFigureOut">
               <a:rPr lang="en-US" smtClean="0"/>
-              <a:t>4/18/2026</a:t>
+              <a:t>5/7/2026</a:t>
             </a:fld>
             <a:endParaRPr lang="en-US"/>
           </a:p>
@@ -2274,7 +2274,7 @@
           <a:p>
             <a:fld id="{51AFF834-1BEC-4F95-9622-28B5DCC1FE16}" type="datetimeFigureOut">
               <a:rPr lang="en-US" smtClean="0"/>
-              <a:t>4/18/2026</a:t>
+              <a:t>5/7/2026</a:t>
             </a:fld>
             <a:endParaRPr lang="en-US"/>
           </a:p>
@@ -2585,7 +2585,7 @@
           <a:p>
             <a:fld id="{51AFF834-1BEC-4F95-9622-28B5DCC1FE16}" type="datetimeFigureOut">
               <a:rPr lang="en-US" smtClean="0"/>
-              <a:t>4/18/2026</a:t>
+              <a:t>5/7/2026</a:t>
             </a:fld>
             <a:endParaRPr lang="en-US"/>
           </a:p>
@@ -2873,7 +2873,7 @@
           <a:p>
             <a:fld id="{51AFF834-1BEC-4F95-9622-28B5DCC1FE16}" type="datetimeFigureOut">
               <a:rPr lang="en-US" smtClean="0"/>
-              <a:t>4/18/2026</a:t>
+              <a:t>5/7/2026</a:t>
             </a:fld>
             <a:endParaRPr lang="en-US"/>
           </a:p>
@@ -3114,7 +3114,7 @@
           <a:p>
             <a:fld id="{51AFF834-1BEC-4F95-9622-28B5DCC1FE16}" type="datetimeFigureOut">
               <a:rPr lang="en-US" smtClean="0"/>
-              <a:t>4/18/2026</a:t>
+              <a:t>5/7/2026</a:t>
             </a:fld>
             <a:endParaRPr lang="en-US"/>
           </a:p>
@@ -5193,7 +5193,7 @@
           </a:prstGeom>
           <a:ln>
             <a:solidFill>
-              <a:srgbClr val="FF0000"/>
+              <a:srgbClr val="7030A0"/>
             </a:solidFill>
             <a:tailEnd type="triangle"/>
           </a:ln>
@@ -5409,50 +5409,6 @@
           </a:fontRef>
         </p:style>
       </p:cxnSp>
-      <p:cxnSp>
-        <p:nvCxnSpPr>
-          <p:cNvPr id="89" name="Straight Arrow Connector 88">
-            <a:extLst>
-              <a:ext uri="{FF2B5EF4-FFF2-40B4-BE49-F238E27FC236}">
-                <a16:creationId xmlns:a16="http://schemas.microsoft.com/office/drawing/2014/main" id="{F54A266D-F4C6-7070-9203-F459E46AE102}"/>
-              </a:ext>
-            </a:extLst>
-          </p:cNvPr>
-          <p:cNvCxnSpPr>
-            <a:cxnSpLocks/>
-          </p:cNvCxnSpPr>
-          <p:nvPr/>
-        </p:nvCxnSpPr>
-        <p:spPr>
-          <a:xfrm>
-            <a:off x="1763837" y="5388092"/>
-            <a:ext cx="475825" cy="0"/>
-          </a:xfrm>
-          <a:prstGeom prst="straightConnector1">
-            <a:avLst/>
-          </a:prstGeom>
-          <a:ln>
-            <a:solidFill>
-              <a:srgbClr val="FF0000"/>
-            </a:solidFill>
-            <a:tailEnd type="triangle"/>
-          </a:ln>
-        </p:spPr>
-        <p:style>
-          <a:lnRef idx="2">
-            <a:schemeClr val="accent1"/>
-          </a:lnRef>
-          <a:fillRef idx="0">
-            <a:schemeClr val="accent1"/>
-          </a:fillRef>
-          <a:effectRef idx="1">
-            <a:schemeClr val="accent1"/>
-          </a:effectRef>
-          <a:fontRef idx="minor">
-            <a:schemeClr val="tx1"/>
-          </a:fontRef>
-        </p:style>
-      </p:cxnSp>
       <p:sp>
         <p:nvSpPr>
           <p:cNvPr id="91" name="TextBox 90">
@@ -6258,12 +6214,17 @@
         </p:nvCxnSpPr>
         <p:spPr>
           <a:xfrm flipH="1">
-            <a:off x="1946513" y="5323322"/>
+            <a:off x="1788420" y="5235512"/>
             <a:ext cx="77899" cy="129540"/>
           </a:xfrm>
           <a:prstGeom prst="line">
             <a:avLst/>
           </a:prstGeom>
+          <a:ln>
+            <a:solidFill>
+              <a:srgbClr val="7030A0"/>
+            </a:solidFill>
+          </a:ln>
         </p:spPr>
         <p:style>
           <a:lnRef idx="2">
@@ -6294,7 +6255,7 @@
         </p:nvSpPr>
         <p:spPr>
           <a:xfrm>
-            <a:off x="1831072" y="5199692"/>
+            <a:off x="1718361" y="5072038"/>
             <a:ext cx="245580" cy="230832"/>
           </a:xfrm>
           <a:prstGeom prst="rect">
@@ -6310,7 +6271,11 @@
           <a:p>
             <a:pPr algn="ctr"/>
             <a:r>
-              <a:rPr lang="en-US" sz="900" dirty="0"/>
+              <a:rPr lang="en-US" sz="900" dirty="0">
+                <a:solidFill>
+                  <a:srgbClr val="7030A0"/>
+                </a:solidFill>
+              </a:rPr>
               <a:t>7</a:t>
             </a:r>
           </a:p>
@@ -6873,6 +6838,9 @@
             <a:avLst/>
           </a:prstGeom>
           <a:ln>
+            <a:solidFill>
+              <a:srgbClr val="7030A0"/>
+            </a:solidFill>
             <a:tailEnd type="triangle"/>
           </a:ln>
         </p:spPr>
@@ -7199,7 +7167,7 @@
           </a:prstGeom>
           <a:ln>
             <a:solidFill>
-              <a:srgbClr val="FF0000"/>
+              <a:srgbClr val="7030A0"/>
             </a:solidFill>
             <a:tailEnd type="triangle"/>
           </a:ln>
@@ -7228,20 +7196,22 @@
               </a:ext>
             </a:extLst>
           </p:cNvPr>
-          <p:cNvCxnSpPr/>
+          <p:cNvCxnSpPr>
+            <a:cxnSpLocks/>
+          </p:cNvCxnSpPr>
           <p:nvPr/>
         </p:nvCxnSpPr>
         <p:spPr>
           <a:xfrm flipV="1">
             <a:off x="6410421" y="3965109"/>
-            <a:ext cx="0" cy="332953"/>
+            <a:ext cx="0" cy="589627"/>
           </a:xfrm>
           <a:prstGeom prst="straightConnector1">
             <a:avLst/>
           </a:prstGeom>
           <a:ln>
             <a:solidFill>
-              <a:srgbClr val="FF0000"/>
+              <a:srgbClr val="7030A0"/>
             </a:solidFill>
             <a:tailEnd type="triangle"/>
           </a:ln>
@@ -7550,20 +7520,22 @@
               </a:ext>
             </a:extLst>
           </p:cNvPr>
-          <p:cNvCxnSpPr/>
+          <p:cNvCxnSpPr>
+            <a:cxnSpLocks/>
+          </p:cNvCxnSpPr>
           <p:nvPr/>
         </p:nvCxnSpPr>
         <p:spPr>
           <a:xfrm flipV="1">
-            <a:off x="8516166" y="3303944"/>
-            <a:ext cx="0" cy="167673"/>
+            <a:off x="8645972" y="3307919"/>
+            <a:ext cx="0" cy="199272"/>
           </a:xfrm>
           <a:prstGeom prst="straightConnector1">
             <a:avLst/>
           </a:prstGeom>
           <a:ln>
             <a:solidFill>
-              <a:srgbClr val="FF0000"/>
+              <a:srgbClr val="7030A0"/>
             </a:solidFill>
             <a:tailEnd type="triangle"/>
           </a:ln>
@@ -7843,7 +7815,7 @@
         </p:nvSpPr>
         <p:spPr>
           <a:xfrm>
-            <a:off x="8373014" y="3114241"/>
+            <a:off x="8516289" y="3111971"/>
             <a:ext cx="287259" cy="230832"/>
           </a:xfrm>
           <a:prstGeom prst="rect">
@@ -8151,6 +8123,11 @@
           <a:prstGeom prst="line">
             <a:avLst/>
           </a:prstGeom>
+          <a:ln>
+            <a:solidFill>
+              <a:srgbClr val="7030A0"/>
+            </a:solidFill>
+          </a:ln>
         </p:spPr>
         <p:style>
           <a:lnRef idx="2">
@@ -9192,15 +9169,15 @@
         </p:nvCxnSpPr>
         <p:spPr>
           <a:xfrm>
-            <a:off x="6907069" y="5094338"/>
-            <a:ext cx="229874" cy="0"/>
+            <a:off x="7149970" y="5022889"/>
+            <a:ext cx="5742" cy="607051"/>
           </a:xfrm>
           <a:prstGeom prst="straightConnector1">
             <a:avLst/>
           </a:prstGeom>
           <a:ln>
             <a:solidFill>
-              <a:srgbClr val="FF0000"/>
+              <a:srgbClr val="7030A0"/>
             </a:solidFill>
             <a:tailEnd type="triangle"/>
           </a:ln>
@@ -9710,6 +9687,9 @@
             <a:avLst/>
           </a:prstGeom>
           <a:ln>
+            <a:solidFill>
+              <a:srgbClr val="7030A0"/>
+            </a:solidFill>
             <a:tailEnd type="triangle"/>
           </a:ln>
         </p:spPr>
@@ -9752,7 +9732,7 @@
           </a:prstGeom>
           <a:ln>
             <a:solidFill>
-              <a:srgbClr val="FF0000"/>
+              <a:srgbClr val="7030A0"/>
             </a:solidFill>
             <a:tailEnd type="triangle"/>
           </a:ln>
@@ -9833,6 +9813,9 @@
             <a:avLst/>
           </a:prstGeom>
           <a:ln>
+            <a:solidFill>
+              <a:srgbClr val="7030A0"/>
+            </a:solidFill>
             <a:tailEnd type="triangle"/>
           </a:ln>
         </p:spPr>
@@ -10027,6 +10010,11 @@
           <a:prstGeom prst="line">
             <a:avLst/>
           </a:prstGeom>
+          <a:ln>
+            <a:solidFill>
+              <a:srgbClr val="7030A0"/>
+            </a:solidFill>
+          </a:ln>
         </p:spPr>
         <p:style>
           <a:lnRef idx="2">
@@ -10065,6 +10053,11 @@
           <a:prstGeom prst="line">
             <a:avLst/>
           </a:prstGeom>
+          <a:ln>
+            <a:solidFill>
+              <a:srgbClr val="7030A0"/>
+            </a:solidFill>
+          </a:ln>
         </p:spPr>
         <p:style>
           <a:lnRef idx="2">
@@ -10101,6 +10094,11 @@
           <a:prstGeom prst="line">
             <a:avLst/>
           </a:prstGeom>
+          <a:ln>
+            <a:solidFill>
+              <a:srgbClr val="7030A0"/>
+            </a:solidFill>
+          </a:ln>
         </p:spPr>
         <p:style>
           <a:lnRef idx="2">
@@ -10137,6 +10135,11 @@
           <a:prstGeom prst="line">
             <a:avLst/>
           </a:prstGeom>
+          <a:ln>
+            <a:solidFill>
+              <a:srgbClr val="7030A0"/>
+            </a:solidFill>
+          </a:ln>
         </p:spPr>
         <p:style>
           <a:lnRef idx="2">
@@ -10175,7 +10178,7 @@
           </a:prstGeom>
           <a:ln>
             <a:solidFill>
-              <a:srgbClr val="FF0000"/>
+              <a:srgbClr val="7030A0"/>
             </a:solidFill>
             <a:tailEnd type="triangle"/>
           </a:ln>
@@ -10250,8 +10253,8 @@
         </p:nvSpPr>
         <p:spPr>
           <a:xfrm>
-            <a:off x="3310209" y="1961292"/>
-            <a:ext cx="413896" cy="230832"/>
+            <a:off x="3187268" y="1880504"/>
+            <a:ext cx="633508" cy="230832"/>
           </a:xfrm>
           <a:prstGeom prst="rect">
             <a:avLst/>
@@ -10266,9 +10269,18 @@
           <a:p>
             <a:pPr algn="ctr"/>
             <a:r>
-              <a:rPr lang="en-US" sz="900" dirty="0"/>
-              <a:t>NPC</a:t>
-            </a:r>
+              <a:rPr lang="en-US" sz="900" dirty="0" err="1">
+                <a:solidFill>
+                  <a:srgbClr val="7030A0"/>
+                </a:solidFill>
+              </a:rPr>
+              <a:t>if_id_npc</a:t>
+            </a:r>
+            <a:endParaRPr lang="en-US" sz="900" dirty="0">
+              <a:solidFill>
+                <a:srgbClr val="7030A0"/>
+              </a:solidFill>
+            </a:endParaRPr>
           </a:p>
         </p:txBody>
       </p:sp>
@@ -10286,8 +10298,8 @@
         </p:nvSpPr>
         <p:spPr>
           <a:xfrm>
-            <a:off x="3313362" y="2376665"/>
-            <a:ext cx="407484" cy="230832"/>
+            <a:off x="3167536" y="2297053"/>
+            <a:ext cx="667170" cy="230832"/>
           </a:xfrm>
           <a:prstGeom prst="rect">
             <a:avLst/>
@@ -10302,10 +10314,18 @@
           <a:p>
             <a:pPr algn="ctr"/>
             <a:r>
-              <a:rPr lang="en-US" sz="900" dirty="0" err="1"/>
-              <a:t>imm</a:t>
-            </a:r>
-            <a:endParaRPr lang="en-US" sz="900" dirty="0"/>
+              <a:rPr lang="en-US" sz="900" dirty="0" err="1">
+                <a:solidFill>
+                  <a:srgbClr val="7030A0"/>
+                </a:solidFill>
+              </a:rPr>
+              <a:t>if_id_imm</a:t>
+            </a:r>
+            <a:endParaRPr lang="en-US" sz="900" dirty="0">
+              <a:solidFill>
+                <a:srgbClr val="7030A0"/>
+              </a:solidFill>
+            </a:endParaRPr>
           </a:p>
         </p:txBody>
       </p:sp>
@@ -10689,13 +10709,16 @@
         </p:nvCxnSpPr>
         <p:spPr>
           <a:xfrm>
-            <a:off x="3675459" y="2502142"/>
-            <a:ext cx="173935" cy="0"/>
+            <a:off x="2757013" y="2502142"/>
+            <a:ext cx="1092381" cy="0"/>
           </a:xfrm>
           <a:prstGeom prst="straightConnector1">
             <a:avLst/>
           </a:prstGeom>
           <a:ln>
+            <a:solidFill>
+              <a:srgbClr val="7030A0"/>
+            </a:solidFill>
             <a:tailEnd type="triangle"/>
           </a:ln>
         </p:spPr>
@@ -10723,18 +10746,23 @@
               </a:ext>
             </a:extLst>
           </p:cNvPr>
-          <p:cNvCxnSpPr/>
+          <p:cNvCxnSpPr>
+            <a:cxnSpLocks/>
+          </p:cNvCxnSpPr>
           <p:nvPr/>
         </p:nvCxnSpPr>
         <p:spPr>
           <a:xfrm>
-            <a:off x="3671586" y="2077026"/>
-            <a:ext cx="177808" cy="0"/>
+            <a:off x="2751488" y="2077026"/>
+            <a:ext cx="1097906" cy="0"/>
           </a:xfrm>
           <a:prstGeom prst="straightConnector1">
             <a:avLst/>
           </a:prstGeom>
           <a:ln>
+            <a:solidFill>
+              <a:srgbClr val="7030A0"/>
+            </a:solidFill>
             <a:tailEnd type="triangle"/>
           </a:ln>
         </p:spPr>
@@ -11005,15 +11033,15 @@
         </p:nvCxnSpPr>
         <p:spPr>
           <a:xfrm flipV="1">
-            <a:off x="10997645" y="4034709"/>
-            <a:ext cx="0" cy="616523"/>
+            <a:off x="10969389" y="4063048"/>
+            <a:ext cx="0" cy="143755"/>
           </a:xfrm>
           <a:prstGeom prst="straightConnector1">
             <a:avLst/>
           </a:prstGeom>
           <a:ln>
             <a:solidFill>
-              <a:srgbClr val="FF0000"/>
+              <a:srgbClr val="7030A0"/>
             </a:solidFill>
             <a:tailEnd type="triangle"/>
           </a:ln>
@@ -11049,12 +11077,17 @@
         </p:nvCxnSpPr>
         <p:spPr>
           <a:xfrm flipH="1">
-            <a:off x="10946889" y="4449728"/>
-            <a:ext cx="107051" cy="69157"/>
+            <a:off x="10137220" y="4404783"/>
+            <a:ext cx="1191180" cy="0"/>
           </a:xfrm>
           <a:prstGeom prst="line">
             <a:avLst/>
           </a:prstGeom>
+          <a:ln>
+            <a:solidFill>
+              <a:srgbClr val="7030A0"/>
+            </a:solidFill>
+          </a:ln>
         </p:spPr>
         <p:style>
           <a:lnRef idx="2">
@@ -11093,6 +11126,11 @@
           <a:prstGeom prst="line">
             <a:avLst/>
           </a:prstGeom>
+          <a:ln>
+            <a:solidFill>
+              <a:srgbClr val="7030A0"/>
+            </a:solidFill>
+          </a:ln>
         </p:spPr>
         <p:style>
           <a:lnRef idx="2">
@@ -11126,55 +11164,17 @@
         <p:spPr>
           <a:xfrm flipV="1">
             <a:off x="4871195" y="2834512"/>
-            <a:ext cx="0" cy="318976"/>
+            <a:ext cx="0" cy="201517"/>
           </a:xfrm>
           <a:prstGeom prst="straightConnector1">
             <a:avLst/>
           </a:prstGeom>
           <a:ln>
             <a:solidFill>
-              <a:srgbClr val="FF0000"/>
+              <a:srgbClr val="7030A0"/>
             </a:solidFill>
             <a:tailEnd type="triangle"/>
           </a:ln>
-        </p:spPr>
-        <p:style>
-          <a:lnRef idx="2">
-            <a:schemeClr val="accent1"/>
-          </a:lnRef>
-          <a:fillRef idx="0">
-            <a:schemeClr val="accent1"/>
-          </a:fillRef>
-          <a:effectRef idx="1">
-            <a:schemeClr val="accent1"/>
-          </a:effectRef>
-          <a:fontRef idx="minor">
-            <a:schemeClr val="tx1"/>
-          </a:fontRef>
-        </p:style>
-      </p:cxnSp>
-      <p:cxnSp>
-        <p:nvCxnSpPr>
-          <p:cNvPr id="148" name="Straight Connector 147">
-            <a:extLst>
-              <a:ext uri="{FF2B5EF4-FFF2-40B4-BE49-F238E27FC236}">
-                <a16:creationId xmlns:a16="http://schemas.microsoft.com/office/drawing/2014/main" id="{FE9EFFB0-0DED-2330-8209-FC39718441DD}"/>
-              </a:ext>
-            </a:extLst>
-          </p:cNvPr>
-          <p:cNvCxnSpPr>
-            <a:cxnSpLocks/>
-          </p:cNvCxnSpPr>
-          <p:nvPr/>
-        </p:nvCxnSpPr>
-        <p:spPr>
-          <a:xfrm flipH="1">
-            <a:off x="4827227" y="3020434"/>
-            <a:ext cx="85431" cy="62194"/>
-          </a:xfrm>
-          <a:prstGeom prst="line">
-            <a:avLst/>
-          </a:prstGeom>
         </p:spPr>
         <p:style>
           <a:lnRef idx="2">
@@ -11214,6 +11214,9 @@
             <a:avLst/>
           </a:prstGeom>
           <a:ln>
+            <a:solidFill>
+              <a:srgbClr val="7030A0"/>
+            </a:solidFill>
             <a:tailEnd type="triangle"/>
           </a:ln>
         </p:spPr>
@@ -11246,8 +11249,8 @@
         </p:nvSpPr>
         <p:spPr>
           <a:xfrm>
-            <a:off x="4444698" y="1106312"/>
-            <a:ext cx="474810" cy="230832"/>
+            <a:off x="5542885" y="1275911"/>
+            <a:ext cx="1154483" cy="230832"/>
           </a:xfrm>
           <a:prstGeom prst="rect">
             <a:avLst/>
@@ -11262,9 +11265,18 @@
           <a:p>
             <a:pPr algn="ctr"/>
             <a:r>
-              <a:rPr lang="en-US" sz="900" dirty="0"/>
-              <a:t>dout1</a:t>
-            </a:r>
+              <a:rPr lang="en-US" sz="900" dirty="0" err="1">
+                <a:solidFill>
+                  <a:srgbClr val="7030A0"/>
+                </a:solidFill>
+              </a:rPr>
+              <a:t>ex_mem_alu_result</a:t>
+            </a:r>
+            <a:endParaRPr lang="en-US" sz="900" dirty="0">
+              <a:solidFill>
+                <a:srgbClr val="7030A0"/>
+              </a:solidFill>
+            </a:endParaRPr>
           </a:p>
         </p:txBody>
       </p:sp>
@@ -11292,7 +11304,7 @@
           </a:prstGeom>
           <a:ln>
             <a:solidFill>
-              <a:srgbClr val="FF0000"/>
+              <a:srgbClr val="7030A0"/>
             </a:solidFill>
             <a:tailEnd type="triangle"/>
           </a:ln>
@@ -11423,6 +11435,9 @@
             <a:avLst/>
           </a:prstGeom>
           <a:ln>
+            <a:solidFill>
+              <a:srgbClr val="7030A0"/>
+            </a:solidFill>
             <a:tailEnd type="triangle"/>
           </a:ln>
         </p:spPr>
@@ -11455,8 +11470,8 @@
         </p:nvSpPr>
         <p:spPr>
           <a:xfrm>
-            <a:off x="4801135" y="1092519"/>
-            <a:ext cx="474810" cy="230832"/>
+            <a:off x="3306254" y="1090777"/>
+            <a:ext cx="936474" cy="230832"/>
           </a:xfrm>
           <a:prstGeom prst="rect">
             <a:avLst/>
@@ -11471,8 +11486,12 @@
           <a:p>
             <a:pPr algn="ctr"/>
             <a:r>
-              <a:rPr lang="en-US" sz="900" dirty="0"/>
-              <a:t>dout2</a:t>
+              <a:rPr lang="en-US" sz="900" dirty="0">
+                <a:solidFill>
+                  <a:srgbClr val="7030A0"/>
+                </a:solidFill>
+              </a:rPr>
+              <a:t>if_id_reg2_data</a:t>
             </a:r>
           </a:p>
         </p:txBody>
@@ -11486,20 +11505,22 @@
               </a:ext>
             </a:extLst>
           </p:cNvPr>
-          <p:cNvCxnSpPr/>
+          <p:cNvCxnSpPr>
+            <a:cxnSpLocks/>
+          </p:cNvCxnSpPr>
           <p:nvPr/>
         </p:nvCxnSpPr>
         <p:spPr>
           <a:xfrm flipV="1">
             <a:off x="8862876" y="3303944"/>
-            <a:ext cx="0" cy="167673"/>
+            <a:ext cx="0" cy="351899"/>
           </a:xfrm>
           <a:prstGeom prst="straightConnector1">
             <a:avLst/>
           </a:prstGeom>
           <a:ln>
             <a:solidFill>
-              <a:srgbClr val="FF0000"/>
+              <a:srgbClr val="7030A0"/>
             </a:solidFill>
             <a:tailEnd type="triangle"/>
           </a:ln>
@@ -11638,7 +11659,7 @@
           </a:prstGeom>
           <a:ln>
             <a:solidFill>
-              <a:srgbClr val="FF0000"/>
+              <a:srgbClr val="7030A0"/>
             </a:solidFill>
             <a:tailEnd type="triangle"/>
           </a:ln>
@@ -11777,7 +11798,7 @@
           </a:prstGeom>
           <a:ln>
             <a:solidFill>
-              <a:srgbClr val="FF0000"/>
+              <a:srgbClr val="7030A0"/>
             </a:solidFill>
             <a:tailEnd type="triangle"/>
           </a:ln>
@@ -11821,7 +11842,7 @@
           </a:prstGeom>
           <a:ln>
             <a:solidFill>
-              <a:srgbClr val="FF0000"/>
+              <a:srgbClr val="7030A0"/>
             </a:solidFill>
             <a:tailEnd type="triangle"/>
           </a:ln>
@@ -11865,7 +11886,7 @@
           </a:prstGeom>
           <a:ln>
             <a:solidFill>
-              <a:srgbClr val="FF0000"/>
+              <a:srgbClr val="7030A0"/>
             </a:solidFill>
           </a:ln>
         </p:spPr>
@@ -11908,7 +11929,7 @@
           </a:prstGeom>
           <a:ln>
             <a:solidFill>
-              <a:srgbClr val="FF0000"/>
+              <a:srgbClr val="7030A0"/>
             </a:solidFill>
             <a:tailEnd type="triangle"/>
           </a:ln>
@@ -11952,7 +11973,7 @@
           </a:prstGeom>
           <a:ln>
             <a:solidFill>
-              <a:srgbClr val="FF0000"/>
+              <a:srgbClr val="7030A0"/>
             </a:solidFill>
           </a:ln>
         </p:spPr>
@@ -11995,7 +12016,7 @@
           </a:prstGeom>
           <a:ln>
             <a:solidFill>
-              <a:srgbClr val="FF0000"/>
+              <a:srgbClr val="7030A0"/>
             </a:solidFill>
           </a:ln>
         </p:spPr>
@@ -12038,7 +12059,7 @@
           </a:prstGeom>
           <a:ln>
             <a:solidFill>
-              <a:srgbClr val="FF0000"/>
+              <a:srgbClr val="7030A0"/>
             </a:solidFill>
           </a:ln>
         </p:spPr>
@@ -12081,7 +12102,7 @@
           </a:prstGeom>
           <a:ln>
             <a:solidFill>
-              <a:srgbClr val="FF0000"/>
+              <a:srgbClr val="7030A0"/>
             </a:solidFill>
             <a:tailEnd type="triangle"/>
           </a:ln>
@@ -12125,7 +12146,7 @@
           </a:prstGeom>
           <a:ln>
             <a:solidFill>
-              <a:srgbClr val="FF0000"/>
+              <a:srgbClr val="7030A0"/>
             </a:solidFill>
             <a:tailEnd type="triangle"/>
           </a:ln>
@@ -12165,6 +12186,11 @@
           <a:prstGeom prst="line">
             <a:avLst/>
           </a:prstGeom>
+          <a:ln>
+            <a:solidFill>
+              <a:srgbClr val="7030A0"/>
+            </a:solidFill>
+          </a:ln>
         </p:spPr>
         <p:style>
           <a:lnRef idx="2">
@@ -12195,7 +12221,7 @@
         </p:nvSpPr>
         <p:spPr>
           <a:xfrm>
-            <a:off x="2834608" y="5072614"/>
+            <a:off x="2848967" y="5046260"/>
             <a:ext cx="245580" cy="230832"/>
           </a:xfrm>
           <a:prstGeom prst="rect">
@@ -12211,7 +12237,11 @@
           <a:p>
             <a:pPr algn="ctr"/>
             <a:r>
-              <a:rPr lang="en-US" sz="900" dirty="0"/>
+              <a:rPr lang="en-US" sz="900" dirty="0">
+                <a:solidFill>
+                  <a:srgbClr val="7030A0"/>
+                </a:solidFill>
+              </a:rPr>
               <a:t>4</a:t>
             </a:r>
           </a:p>
@@ -12330,7 +12360,7 @@
           </a:prstGeom>
           <a:ln>
             <a:solidFill>
-              <a:srgbClr val="FF0000"/>
+              <a:srgbClr val="7030A0"/>
             </a:solidFill>
             <a:tailEnd type="triangle"/>
           </a:ln>
@@ -12374,7 +12404,7 @@
           </a:prstGeom>
           <a:ln>
             <a:solidFill>
-              <a:srgbClr val="FF0000"/>
+              <a:srgbClr val="7030A0"/>
             </a:solidFill>
             <a:tailEnd type="triangle"/>
           </a:ln>
@@ -12424,7 +12454,11 @@
           <a:p>
             <a:pPr algn="ctr"/>
             <a:r>
-              <a:rPr lang="en-US" sz="900" dirty="0"/>
+              <a:rPr lang="en-US" sz="900" dirty="0">
+                <a:solidFill>
+                  <a:srgbClr val="7030A0"/>
+                </a:solidFill>
+              </a:rPr>
               <a:t>0</a:t>
             </a:r>
           </a:p>
@@ -12460,7 +12494,11 @@
           <a:p>
             <a:pPr algn="ctr"/>
             <a:r>
-              <a:rPr lang="en-US" sz="1000" dirty="0"/>
+              <a:rPr lang="en-US" sz="1000" dirty="0">
+                <a:solidFill>
+                  <a:srgbClr val="7030A0"/>
+                </a:solidFill>
+              </a:rPr>
               <a:t>Stall</a:t>
             </a:r>
           </a:p>
@@ -12480,8 +12518,8 @@
         </p:nvSpPr>
         <p:spPr>
           <a:xfrm>
-            <a:off x="3408450" y="6047112"/>
-            <a:ext cx="861489" cy="246221"/>
+            <a:off x="3331232" y="6006780"/>
+            <a:ext cx="909879" cy="246221"/>
           </a:xfrm>
           <a:prstGeom prst="rect">
             <a:avLst/>
@@ -12496,10 +12534,18 @@
           <a:p>
             <a:pPr algn="ctr"/>
             <a:r>
-              <a:rPr lang="en-US" sz="1000" dirty="0" err="1"/>
-              <a:t>stall_count</a:t>
-            </a:r>
-            <a:endParaRPr lang="en-US" sz="1000" dirty="0"/>
+              <a:rPr lang="en-US" sz="1000" dirty="0" err="1">
+                <a:solidFill>
+                  <a:srgbClr val="7030A0"/>
+                </a:solidFill>
+              </a:rPr>
+              <a:t>stall_counter</a:t>
+            </a:r>
+            <a:endParaRPr lang="en-US" sz="1000" dirty="0">
+              <a:solidFill>
+                <a:srgbClr val="7030A0"/>
+              </a:solidFill>
+            </a:endParaRPr>
           </a:p>
         </p:txBody>
       </p:sp>
@@ -12517,8 +12563,8 @@
         </p:nvSpPr>
         <p:spPr>
           <a:xfrm>
-            <a:off x="3685159" y="5311002"/>
-            <a:ext cx="861489" cy="246221"/>
+            <a:off x="3340891" y="5296039"/>
+            <a:ext cx="1713528" cy="246221"/>
           </a:xfrm>
           <a:prstGeom prst="rect">
             <a:avLst/>
@@ -12533,10 +12579,34 @@
           <a:p>
             <a:pPr algn="ctr"/>
             <a:r>
-              <a:rPr lang="en-US" sz="1000" dirty="0" err="1"/>
+              <a:rPr lang="en-US" sz="1000" dirty="0" err="1">
+                <a:solidFill>
+                  <a:srgbClr val="7030A0"/>
+                </a:solidFill>
+              </a:rPr>
               <a:t>start_stall</a:t>
             </a:r>
-            <a:endParaRPr lang="en-US" sz="1000" dirty="0"/>
+            <a:r>
+              <a:rPr lang="en-US" sz="1000" dirty="0">
+                <a:solidFill>
+                  <a:srgbClr val="7030A0"/>
+                </a:solidFill>
+              </a:rPr>
+              <a:t> &amp; </a:t>
+            </a:r>
+            <a:r>
+              <a:rPr lang="en-US" sz="1000" dirty="0" err="1">
+                <a:solidFill>
+                  <a:srgbClr val="7030A0"/>
+                </a:solidFill>
+              </a:rPr>
+              <a:t>start_double</a:t>
+            </a:r>
+            <a:endParaRPr lang="en-US" sz="1000" dirty="0">
+              <a:solidFill>
+                <a:srgbClr val="7030A0"/>
+              </a:solidFill>
+            </a:endParaRPr>
           </a:p>
         </p:txBody>
       </p:sp>
@@ -12556,7 +12626,7 @@
         </p:nvCxnSpPr>
         <p:spPr>
           <a:xfrm>
-            <a:off x="3472911" y="6051625"/>
+            <a:off x="3360444" y="6070064"/>
             <a:ext cx="0" cy="402752"/>
           </a:xfrm>
           <a:prstGeom prst="straightConnector1">
@@ -12564,7 +12634,7 @@
           </a:prstGeom>
           <a:ln>
             <a:solidFill>
-              <a:srgbClr val="FF0000"/>
+              <a:srgbClr val="7030A0"/>
             </a:solidFill>
             <a:tailEnd type="triangle"/>
           </a:ln>
@@ -12598,7 +12668,7 @@
         </p:nvSpPr>
         <p:spPr>
           <a:xfrm>
-            <a:off x="2990194" y="6420855"/>
+            <a:off x="2905202" y="6420855"/>
             <a:ext cx="935914" cy="246221"/>
           </a:xfrm>
           <a:prstGeom prst="rect">
@@ -12614,13 +12684,2768 @@
           <a:p>
             <a:pPr algn="ctr"/>
             <a:r>
-              <a:rPr lang="en-US" sz="1000" dirty="0" err="1"/>
+              <a:rPr lang="en-US" sz="1000" dirty="0" err="1">
+                <a:solidFill>
+                  <a:srgbClr val="7030A0"/>
+                </a:solidFill>
+              </a:rPr>
               <a:t>double_stall</a:t>
             </a:r>
-            <a:endParaRPr lang="en-US" sz="1000" dirty="0"/>
-          </a:p>
-        </p:txBody>
-      </p:sp>
+            <a:endParaRPr lang="en-US" sz="1000" dirty="0">
+              <a:solidFill>
+                <a:srgbClr val="7030A0"/>
+              </a:solidFill>
+            </a:endParaRPr>
+          </a:p>
+        </p:txBody>
+      </p:sp>
+      <p:cxnSp>
+        <p:nvCxnSpPr>
+          <p:cNvPr id="26" name="Straight Connector 25">
+            <a:extLst>
+              <a:ext uri="{FF2B5EF4-FFF2-40B4-BE49-F238E27FC236}">
+                <a16:creationId xmlns:a16="http://schemas.microsoft.com/office/drawing/2014/main" id="{091A9D4D-23BC-B2EA-D780-4B2E4256AC4E}"/>
+              </a:ext>
+            </a:extLst>
+          </p:cNvPr>
+          <p:cNvCxnSpPr>
+            <a:cxnSpLocks/>
+          </p:cNvCxnSpPr>
+          <p:nvPr/>
+        </p:nvCxnSpPr>
+        <p:spPr>
+          <a:xfrm flipH="1">
+            <a:off x="1763837" y="5304401"/>
+            <a:ext cx="231201" cy="0"/>
+          </a:xfrm>
+          <a:prstGeom prst="line">
+            <a:avLst/>
+          </a:prstGeom>
+          <a:ln>
+            <a:solidFill>
+              <a:srgbClr val="7030A0"/>
+            </a:solidFill>
+          </a:ln>
+        </p:spPr>
+        <p:style>
+          <a:lnRef idx="2">
+            <a:schemeClr val="accent1"/>
+          </a:lnRef>
+          <a:fillRef idx="0">
+            <a:schemeClr val="accent1"/>
+          </a:fillRef>
+          <a:effectRef idx="1">
+            <a:schemeClr val="accent1"/>
+          </a:effectRef>
+          <a:fontRef idx="minor">
+            <a:schemeClr val="tx1"/>
+          </a:fontRef>
+        </p:style>
+      </p:cxnSp>
+      <p:cxnSp>
+        <p:nvCxnSpPr>
+          <p:cNvPr id="252" name="Straight Connector 251">
+            <a:extLst>
+              <a:ext uri="{FF2B5EF4-FFF2-40B4-BE49-F238E27FC236}">
+                <a16:creationId xmlns:a16="http://schemas.microsoft.com/office/drawing/2014/main" id="{101BDF42-21C1-1B12-B47E-159B1F1223C4}"/>
+              </a:ext>
+            </a:extLst>
+          </p:cNvPr>
+          <p:cNvCxnSpPr>
+            <a:cxnSpLocks/>
+          </p:cNvCxnSpPr>
+          <p:nvPr/>
+        </p:nvCxnSpPr>
+        <p:spPr>
+          <a:xfrm flipH="1">
+            <a:off x="1988425" y="4650852"/>
+            <a:ext cx="3374" cy="1129203"/>
+          </a:xfrm>
+          <a:prstGeom prst="line">
+            <a:avLst/>
+          </a:prstGeom>
+          <a:ln>
+            <a:solidFill>
+              <a:srgbClr val="7030A0"/>
+            </a:solidFill>
+          </a:ln>
+        </p:spPr>
+        <p:style>
+          <a:lnRef idx="2">
+            <a:schemeClr val="accent1"/>
+          </a:lnRef>
+          <a:fillRef idx="0">
+            <a:schemeClr val="accent1"/>
+          </a:fillRef>
+          <a:effectRef idx="1">
+            <a:schemeClr val="accent1"/>
+          </a:effectRef>
+          <a:fontRef idx="minor">
+            <a:schemeClr val="tx1"/>
+          </a:fontRef>
+        </p:style>
+      </p:cxnSp>
+      <p:cxnSp>
+        <p:nvCxnSpPr>
+          <p:cNvPr id="32" name="Straight Connector 31">
+            <a:extLst>
+              <a:ext uri="{FF2B5EF4-FFF2-40B4-BE49-F238E27FC236}">
+                <a16:creationId xmlns:a16="http://schemas.microsoft.com/office/drawing/2014/main" id="{42EB8A92-37A3-C399-9C12-F59E88DAC482}"/>
+              </a:ext>
+            </a:extLst>
+          </p:cNvPr>
+          <p:cNvCxnSpPr>
+            <a:cxnSpLocks/>
+          </p:cNvCxnSpPr>
+          <p:nvPr/>
+        </p:nvCxnSpPr>
+        <p:spPr>
+          <a:xfrm flipH="1">
+            <a:off x="1983880" y="4661162"/>
+            <a:ext cx="115941" cy="0"/>
+          </a:xfrm>
+          <a:prstGeom prst="line">
+            <a:avLst/>
+          </a:prstGeom>
+          <a:ln>
+            <a:solidFill>
+              <a:srgbClr val="7030A0"/>
+            </a:solidFill>
+          </a:ln>
+        </p:spPr>
+        <p:style>
+          <a:lnRef idx="2">
+            <a:schemeClr val="accent1"/>
+          </a:lnRef>
+          <a:fillRef idx="0">
+            <a:schemeClr val="accent1"/>
+          </a:fillRef>
+          <a:effectRef idx="1">
+            <a:schemeClr val="accent1"/>
+          </a:effectRef>
+          <a:fontRef idx="minor">
+            <a:schemeClr val="tx1"/>
+          </a:fontRef>
+        </p:style>
+      </p:cxnSp>
+      <p:cxnSp>
+        <p:nvCxnSpPr>
+          <p:cNvPr id="35" name="Straight Connector 34">
+            <a:extLst>
+              <a:ext uri="{FF2B5EF4-FFF2-40B4-BE49-F238E27FC236}">
+                <a16:creationId xmlns:a16="http://schemas.microsoft.com/office/drawing/2014/main" id="{940E0D66-37FE-21F2-B9CE-8D1ED73238A6}"/>
+              </a:ext>
+            </a:extLst>
+          </p:cNvPr>
+          <p:cNvCxnSpPr>
+            <a:cxnSpLocks/>
+          </p:cNvCxnSpPr>
+          <p:nvPr/>
+        </p:nvCxnSpPr>
+        <p:spPr>
+          <a:xfrm flipH="1">
+            <a:off x="1983880" y="5777549"/>
+            <a:ext cx="115941" cy="0"/>
+          </a:xfrm>
+          <a:prstGeom prst="line">
+            <a:avLst/>
+          </a:prstGeom>
+          <a:ln>
+            <a:solidFill>
+              <a:srgbClr val="7030A0"/>
+            </a:solidFill>
+          </a:ln>
+        </p:spPr>
+        <p:style>
+          <a:lnRef idx="2">
+            <a:schemeClr val="accent1"/>
+          </a:lnRef>
+          <a:fillRef idx="0">
+            <a:schemeClr val="accent1"/>
+          </a:fillRef>
+          <a:effectRef idx="1">
+            <a:schemeClr val="accent1"/>
+          </a:effectRef>
+          <a:fontRef idx="minor">
+            <a:schemeClr val="tx1"/>
+          </a:fontRef>
+        </p:style>
+      </p:cxnSp>
+      <p:cxnSp>
+        <p:nvCxnSpPr>
+          <p:cNvPr id="47" name="Straight Connector 46">
+            <a:extLst>
+              <a:ext uri="{FF2B5EF4-FFF2-40B4-BE49-F238E27FC236}">
+                <a16:creationId xmlns:a16="http://schemas.microsoft.com/office/drawing/2014/main" id="{7DA260CB-D651-8B6C-B01D-782F8108101F}"/>
+              </a:ext>
+            </a:extLst>
+          </p:cNvPr>
+          <p:cNvCxnSpPr>
+            <a:cxnSpLocks/>
+          </p:cNvCxnSpPr>
+          <p:nvPr/>
+        </p:nvCxnSpPr>
+        <p:spPr>
+          <a:xfrm flipH="1">
+            <a:off x="1995038" y="5199692"/>
+            <a:ext cx="115941" cy="0"/>
+          </a:xfrm>
+          <a:prstGeom prst="line">
+            <a:avLst/>
+          </a:prstGeom>
+          <a:ln>
+            <a:solidFill>
+              <a:srgbClr val="7030A0"/>
+            </a:solidFill>
+          </a:ln>
+        </p:spPr>
+        <p:style>
+          <a:lnRef idx="2">
+            <a:schemeClr val="accent1"/>
+          </a:lnRef>
+          <a:fillRef idx="0">
+            <a:schemeClr val="accent1"/>
+          </a:fillRef>
+          <a:effectRef idx="1">
+            <a:schemeClr val="accent1"/>
+          </a:effectRef>
+          <a:fontRef idx="minor">
+            <a:schemeClr val="tx1"/>
+          </a:fontRef>
+        </p:style>
+      </p:cxnSp>
+      <p:cxnSp>
+        <p:nvCxnSpPr>
+          <p:cNvPr id="52" name="Straight Connector 51">
+            <a:extLst>
+              <a:ext uri="{FF2B5EF4-FFF2-40B4-BE49-F238E27FC236}">
+                <a16:creationId xmlns:a16="http://schemas.microsoft.com/office/drawing/2014/main" id="{7CDFE0D0-15E9-F856-EE66-3B912BF11A12}"/>
+              </a:ext>
+            </a:extLst>
+          </p:cNvPr>
+          <p:cNvCxnSpPr>
+            <a:cxnSpLocks/>
+          </p:cNvCxnSpPr>
+          <p:nvPr/>
+        </p:nvCxnSpPr>
+        <p:spPr>
+          <a:xfrm flipH="1">
+            <a:off x="1995038" y="4834772"/>
+            <a:ext cx="115941" cy="0"/>
+          </a:xfrm>
+          <a:prstGeom prst="line">
+            <a:avLst/>
+          </a:prstGeom>
+          <a:ln>
+            <a:solidFill>
+              <a:srgbClr val="7030A0"/>
+            </a:solidFill>
+          </a:ln>
+        </p:spPr>
+        <p:style>
+          <a:lnRef idx="2">
+            <a:schemeClr val="accent1"/>
+          </a:lnRef>
+          <a:fillRef idx="0">
+            <a:schemeClr val="accent1"/>
+          </a:fillRef>
+          <a:effectRef idx="1">
+            <a:schemeClr val="accent1"/>
+          </a:effectRef>
+          <a:fontRef idx="minor">
+            <a:schemeClr val="tx1"/>
+          </a:fontRef>
+        </p:style>
+      </p:cxnSp>
+      <p:cxnSp>
+        <p:nvCxnSpPr>
+          <p:cNvPr id="53" name="Straight Connector 52">
+            <a:extLst>
+              <a:ext uri="{FF2B5EF4-FFF2-40B4-BE49-F238E27FC236}">
+                <a16:creationId xmlns:a16="http://schemas.microsoft.com/office/drawing/2014/main" id="{18E469D1-9355-C50B-CFF6-970C7B8E0B5A}"/>
+              </a:ext>
+            </a:extLst>
+          </p:cNvPr>
+          <p:cNvCxnSpPr>
+            <a:cxnSpLocks/>
+          </p:cNvCxnSpPr>
+          <p:nvPr/>
+        </p:nvCxnSpPr>
+        <p:spPr>
+          <a:xfrm flipH="1">
+            <a:off x="1995038" y="5022889"/>
+            <a:ext cx="115941" cy="0"/>
+          </a:xfrm>
+          <a:prstGeom prst="line">
+            <a:avLst/>
+          </a:prstGeom>
+          <a:ln>
+            <a:solidFill>
+              <a:srgbClr val="7030A0"/>
+            </a:solidFill>
+          </a:ln>
+        </p:spPr>
+        <p:style>
+          <a:lnRef idx="2">
+            <a:schemeClr val="accent1"/>
+          </a:lnRef>
+          <a:fillRef idx="0">
+            <a:schemeClr val="accent1"/>
+          </a:fillRef>
+          <a:effectRef idx="1">
+            <a:schemeClr val="accent1"/>
+          </a:effectRef>
+          <a:fontRef idx="minor">
+            <a:schemeClr val="tx1"/>
+          </a:fontRef>
+        </p:style>
+      </p:cxnSp>
+      <p:cxnSp>
+        <p:nvCxnSpPr>
+          <p:cNvPr id="58" name="Straight Connector 57">
+            <a:extLst>
+              <a:ext uri="{FF2B5EF4-FFF2-40B4-BE49-F238E27FC236}">
+                <a16:creationId xmlns:a16="http://schemas.microsoft.com/office/drawing/2014/main" id="{C07C7196-A0AB-B2B0-CC9D-92F9A3833EE3}"/>
+              </a:ext>
+            </a:extLst>
+          </p:cNvPr>
+          <p:cNvCxnSpPr>
+            <a:cxnSpLocks/>
+          </p:cNvCxnSpPr>
+          <p:nvPr/>
+        </p:nvCxnSpPr>
+        <p:spPr>
+          <a:xfrm flipH="1">
+            <a:off x="1995038" y="5389125"/>
+            <a:ext cx="115941" cy="0"/>
+          </a:xfrm>
+          <a:prstGeom prst="line">
+            <a:avLst/>
+          </a:prstGeom>
+          <a:ln>
+            <a:solidFill>
+              <a:srgbClr val="7030A0"/>
+            </a:solidFill>
+          </a:ln>
+        </p:spPr>
+        <p:style>
+          <a:lnRef idx="2">
+            <a:schemeClr val="accent1"/>
+          </a:lnRef>
+          <a:fillRef idx="0">
+            <a:schemeClr val="accent1"/>
+          </a:fillRef>
+          <a:effectRef idx="1">
+            <a:schemeClr val="accent1"/>
+          </a:effectRef>
+          <a:fontRef idx="minor">
+            <a:schemeClr val="tx1"/>
+          </a:fontRef>
+        </p:style>
+      </p:cxnSp>
+      <p:cxnSp>
+        <p:nvCxnSpPr>
+          <p:cNvPr id="59" name="Straight Connector 58">
+            <a:extLst>
+              <a:ext uri="{FF2B5EF4-FFF2-40B4-BE49-F238E27FC236}">
+                <a16:creationId xmlns:a16="http://schemas.microsoft.com/office/drawing/2014/main" id="{6516C789-DB2A-D41B-419E-E79684E490C9}"/>
+              </a:ext>
+            </a:extLst>
+          </p:cNvPr>
+          <p:cNvCxnSpPr>
+            <a:cxnSpLocks/>
+          </p:cNvCxnSpPr>
+          <p:nvPr/>
+        </p:nvCxnSpPr>
+        <p:spPr>
+          <a:xfrm flipH="1">
+            <a:off x="1995038" y="5588598"/>
+            <a:ext cx="115941" cy="0"/>
+          </a:xfrm>
+          <a:prstGeom prst="line">
+            <a:avLst/>
+          </a:prstGeom>
+          <a:ln>
+            <a:solidFill>
+              <a:srgbClr val="7030A0"/>
+            </a:solidFill>
+          </a:ln>
+        </p:spPr>
+        <p:style>
+          <a:lnRef idx="2">
+            <a:schemeClr val="accent1"/>
+          </a:lnRef>
+          <a:fillRef idx="0">
+            <a:schemeClr val="accent1"/>
+          </a:fillRef>
+          <a:effectRef idx="1">
+            <a:schemeClr val="accent1"/>
+          </a:effectRef>
+          <a:fontRef idx="minor">
+            <a:schemeClr val="tx1"/>
+          </a:fontRef>
+        </p:style>
+      </p:cxnSp>
+      <p:sp>
+        <p:nvSpPr>
+          <p:cNvPr id="61" name="TextBox 60">
+            <a:extLst>
+              <a:ext uri="{FF2B5EF4-FFF2-40B4-BE49-F238E27FC236}">
+                <a16:creationId xmlns:a16="http://schemas.microsoft.com/office/drawing/2014/main" id="{278D02DD-B4C9-A143-59C2-73F8EDB1C5B2}"/>
+              </a:ext>
+            </a:extLst>
+          </p:cNvPr>
+          <p:cNvSpPr txBox="1"/>
+          <p:nvPr/>
+        </p:nvSpPr>
+        <p:spPr>
+          <a:xfrm>
+            <a:off x="1917139" y="4524741"/>
+            <a:ext cx="935914" cy="246221"/>
+          </a:xfrm>
+          <a:prstGeom prst="rect">
+            <a:avLst/>
+          </a:prstGeom>
+          <a:noFill/>
+        </p:spPr>
+        <p:txBody>
+          <a:bodyPr wrap="square" rtlCol="0">
+            <a:spAutoFit/>
+          </a:bodyPr>
+          <a:lstStyle/>
+          <a:p>
+            <a:pPr algn="ctr"/>
+            <a:r>
+              <a:rPr lang="en-US" sz="1000" dirty="0" err="1">
+                <a:solidFill>
+                  <a:srgbClr val="7030A0"/>
+                </a:solidFill>
+              </a:rPr>
+              <a:t>reg_write</a:t>
+            </a:r>
+            <a:endParaRPr lang="en-US" sz="1000" dirty="0">
+              <a:solidFill>
+                <a:srgbClr val="7030A0"/>
+              </a:solidFill>
+            </a:endParaRPr>
+          </a:p>
+        </p:txBody>
+      </p:sp>
+      <p:sp>
+        <p:nvSpPr>
+          <p:cNvPr id="256" name="TextBox 255">
+            <a:extLst>
+              <a:ext uri="{FF2B5EF4-FFF2-40B4-BE49-F238E27FC236}">
+                <a16:creationId xmlns:a16="http://schemas.microsoft.com/office/drawing/2014/main" id="{8AF4ABE4-2A20-31CE-B28E-06A90757B786}"/>
+              </a:ext>
+            </a:extLst>
+          </p:cNvPr>
+          <p:cNvSpPr txBox="1"/>
+          <p:nvPr/>
+        </p:nvSpPr>
+        <p:spPr>
+          <a:xfrm>
+            <a:off x="1966342" y="4689290"/>
+            <a:ext cx="935914" cy="246221"/>
+          </a:xfrm>
+          <a:prstGeom prst="rect">
+            <a:avLst/>
+          </a:prstGeom>
+          <a:noFill/>
+        </p:spPr>
+        <p:txBody>
+          <a:bodyPr wrap="square" rtlCol="0">
+            <a:spAutoFit/>
+          </a:bodyPr>
+          <a:lstStyle/>
+          <a:p>
+            <a:pPr algn="ctr"/>
+            <a:r>
+              <a:rPr lang="en-US" sz="1000" dirty="0" err="1">
+                <a:solidFill>
+                  <a:srgbClr val="7030A0"/>
+                </a:solidFill>
+              </a:rPr>
+              <a:t>mem_read</a:t>
+            </a:r>
+            <a:endParaRPr lang="en-US" sz="1000" dirty="0">
+              <a:solidFill>
+                <a:srgbClr val="7030A0"/>
+              </a:solidFill>
+            </a:endParaRPr>
+          </a:p>
+        </p:txBody>
+      </p:sp>
+      <p:sp>
+        <p:nvSpPr>
+          <p:cNvPr id="261" name="TextBox 260">
+            <a:extLst>
+              <a:ext uri="{FF2B5EF4-FFF2-40B4-BE49-F238E27FC236}">
+                <a16:creationId xmlns:a16="http://schemas.microsoft.com/office/drawing/2014/main" id="{38248418-D984-5DE4-583A-B45D5D02496B}"/>
+              </a:ext>
+            </a:extLst>
+          </p:cNvPr>
+          <p:cNvSpPr txBox="1"/>
+          <p:nvPr/>
+        </p:nvSpPr>
+        <p:spPr>
+          <a:xfrm>
+            <a:off x="1969994" y="4878672"/>
+            <a:ext cx="935914" cy="246221"/>
+          </a:xfrm>
+          <a:prstGeom prst="rect">
+            <a:avLst/>
+          </a:prstGeom>
+          <a:noFill/>
+        </p:spPr>
+        <p:txBody>
+          <a:bodyPr wrap="square" rtlCol="0">
+            <a:spAutoFit/>
+          </a:bodyPr>
+          <a:lstStyle/>
+          <a:p>
+            <a:pPr algn="ctr"/>
+            <a:r>
+              <a:rPr lang="en-US" sz="1000" dirty="0" err="1">
+                <a:solidFill>
+                  <a:srgbClr val="7030A0"/>
+                </a:solidFill>
+              </a:rPr>
+              <a:t>mem_write</a:t>
+            </a:r>
+            <a:endParaRPr lang="en-US" sz="1000" dirty="0">
+              <a:solidFill>
+                <a:srgbClr val="7030A0"/>
+              </a:solidFill>
+            </a:endParaRPr>
+          </a:p>
+        </p:txBody>
+      </p:sp>
+      <p:sp>
+        <p:nvSpPr>
+          <p:cNvPr id="262" name="TextBox 261">
+            <a:extLst>
+              <a:ext uri="{FF2B5EF4-FFF2-40B4-BE49-F238E27FC236}">
+                <a16:creationId xmlns:a16="http://schemas.microsoft.com/office/drawing/2014/main" id="{E99BA31A-BAEB-4856-3296-765EDFFCC819}"/>
+              </a:ext>
+            </a:extLst>
+          </p:cNvPr>
+          <p:cNvSpPr txBox="1"/>
+          <p:nvPr/>
+        </p:nvSpPr>
+        <p:spPr>
+          <a:xfrm>
+            <a:off x="1890055" y="5069920"/>
+            <a:ext cx="935914" cy="246221"/>
+          </a:xfrm>
+          <a:prstGeom prst="rect">
+            <a:avLst/>
+          </a:prstGeom>
+          <a:noFill/>
+        </p:spPr>
+        <p:txBody>
+          <a:bodyPr wrap="square" rtlCol="0">
+            <a:spAutoFit/>
+          </a:bodyPr>
+          <a:lstStyle/>
+          <a:p>
+            <a:pPr algn="ctr"/>
+            <a:r>
+              <a:rPr lang="en-US" sz="1000" dirty="0" err="1">
+                <a:solidFill>
+                  <a:srgbClr val="7030A0"/>
+                </a:solidFill>
+              </a:rPr>
+              <a:t>alu_src</a:t>
+            </a:r>
+            <a:endParaRPr lang="en-US" sz="1000" dirty="0">
+              <a:solidFill>
+                <a:srgbClr val="7030A0"/>
+              </a:solidFill>
+            </a:endParaRPr>
+          </a:p>
+        </p:txBody>
+      </p:sp>
+      <p:sp>
+        <p:nvSpPr>
+          <p:cNvPr id="263" name="TextBox 262">
+            <a:extLst>
+              <a:ext uri="{FF2B5EF4-FFF2-40B4-BE49-F238E27FC236}">
+                <a16:creationId xmlns:a16="http://schemas.microsoft.com/office/drawing/2014/main" id="{26D58355-817C-8B05-B093-754BFE449697}"/>
+              </a:ext>
+            </a:extLst>
+          </p:cNvPr>
+          <p:cNvSpPr txBox="1"/>
+          <p:nvPr/>
+        </p:nvSpPr>
+        <p:spPr>
+          <a:xfrm>
+            <a:off x="1865694" y="5246240"/>
+            <a:ext cx="935914" cy="246221"/>
+          </a:xfrm>
+          <a:prstGeom prst="rect">
+            <a:avLst/>
+          </a:prstGeom>
+          <a:noFill/>
+        </p:spPr>
+        <p:txBody>
+          <a:bodyPr wrap="square" rtlCol="0">
+            <a:spAutoFit/>
+          </a:bodyPr>
+          <a:lstStyle/>
+          <a:p>
+            <a:pPr algn="ctr"/>
+            <a:r>
+              <a:rPr lang="en-US" sz="1000" dirty="0">
+                <a:solidFill>
+                  <a:srgbClr val="7030A0"/>
+                </a:solidFill>
+              </a:rPr>
+              <a:t>branch</a:t>
+            </a:r>
+          </a:p>
+        </p:txBody>
+      </p:sp>
+      <p:sp>
+        <p:nvSpPr>
+          <p:cNvPr id="264" name="TextBox 263">
+            <a:extLst>
+              <a:ext uri="{FF2B5EF4-FFF2-40B4-BE49-F238E27FC236}">
+                <a16:creationId xmlns:a16="http://schemas.microsoft.com/office/drawing/2014/main" id="{1501B59F-94B8-BDC0-4C78-16DE7E280770}"/>
+              </a:ext>
+            </a:extLst>
+          </p:cNvPr>
+          <p:cNvSpPr txBox="1"/>
+          <p:nvPr/>
+        </p:nvSpPr>
+        <p:spPr>
+          <a:xfrm>
+            <a:off x="1830063" y="5458454"/>
+            <a:ext cx="935914" cy="246221"/>
+          </a:xfrm>
+          <a:prstGeom prst="rect">
+            <a:avLst/>
+          </a:prstGeom>
+          <a:noFill/>
+        </p:spPr>
+        <p:txBody>
+          <a:bodyPr wrap="square" rtlCol="0">
+            <a:spAutoFit/>
+          </a:bodyPr>
+          <a:lstStyle/>
+          <a:p>
+            <a:pPr algn="ctr"/>
+            <a:r>
+              <a:rPr lang="en-US" sz="1000" dirty="0">
+                <a:solidFill>
+                  <a:srgbClr val="7030A0"/>
+                </a:solidFill>
+              </a:rPr>
+              <a:t>jump</a:t>
+            </a:r>
+          </a:p>
+        </p:txBody>
+      </p:sp>
+      <p:sp>
+        <p:nvSpPr>
+          <p:cNvPr id="265" name="TextBox 264">
+            <a:extLst>
+              <a:ext uri="{FF2B5EF4-FFF2-40B4-BE49-F238E27FC236}">
+                <a16:creationId xmlns:a16="http://schemas.microsoft.com/office/drawing/2014/main" id="{A1E6F8C3-BCCC-82CB-F782-8A82C0831610}"/>
+              </a:ext>
+            </a:extLst>
+          </p:cNvPr>
+          <p:cNvSpPr txBox="1"/>
+          <p:nvPr/>
+        </p:nvSpPr>
+        <p:spPr>
+          <a:xfrm>
+            <a:off x="1946067" y="5631323"/>
+            <a:ext cx="935914" cy="246221"/>
+          </a:xfrm>
+          <a:prstGeom prst="rect">
+            <a:avLst/>
+          </a:prstGeom>
+          <a:noFill/>
+        </p:spPr>
+        <p:txBody>
+          <a:bodyPr wrap="square" rtlCol="0">
+            <a:spAutoFit/>
+          </a:bodyPr>
+          <a:lstStyle/>
+          <a:p>
+            <a:pPr algn="ctr"/>
+            <a:r>
+              <a:rPr lang="en-US" sz="1000" dirty="0" err="1">
+                <a:solidFill>
+                  <a:srgbClr val="7030A0"/>
+                </a:solidFill>
+              </a:rPr>
+              <a:t>load_addr</a:t>
+            </a:r>
+            <a:endParaRPr lang="en-US" sz="1000" dirty="0">
+              <a:solidFill>
+                <a:srgbClr val="7030A0"/>
+              </a:solidFill>
+            </a:endParaRPr>
+          </a:p>
+        </p:txBody>
+      </p:sp>
+      <p:sp>
+        <p:nvSpPr>
+          <p:cNvPr id="266" name="TextBox 265">
+            <a:extLst>
+              <a:ext uri="{FF2B5EF4-FFF2-40B4-BE49-F238E27FC236}">
+                <a16:creationId xmlns:a16="http://schemas.microsoft.com/office/drawing/2014/main" id="{165965E2-9B39-C1AB-84A8-03F73E0F0210}"/>
+              </a:ext>
+            </a:extLst>
+          </p:cNvPr>
+          <p:cNvSpPr txBox="1"/>
+          <p:nvPr/>
+        </p:nvSpPr>
+        <p:spPr>
+          <a:xfrm>
+            <a:off x="2386924" y="6111030"/>
+            <a:ext cx="602058" cy="246221"/>
+          </a:xfrm>
+          <a:prstGeom prst="rect">
+            <a:avLst/>
+          </a:prstGeom>
+          <a:noFill/>
+        </p:spPr>
+        <p:txBody>
+          <a:bodyPr wrap="square" rtlCol="0">
+            <a:spAutoFit/>
+          </a:bodyPr>
+          <a:lstStyle/>
+          <a:p>
+            <a:pPr algn="ctr"/>
+            <a:r>
+              <a:rPr lang="en-US" sz="1000" dirty="0" err="1">
+                <a:solidFill>
+                  <a:srgbClr val="7030A0"/>
+                </a:solidFill>
+              </a:rPr>
+              <a:t>alu_op</a:t>
+            </a:r>
+            <a:endParaRPr lang="en-US" sz="1000" dirty="0">
+              <a:solidFill>
+                <a:srgbClr val="7030A0"/>
+              </a:solidFill>
+            </a:endParaRPr>
+          </a:p>
+        </p:txBody>
+      </p:sp>
+      <p:cxnSp>
+        <p:nvCxnSpPr>
+          <p:cNvPr id="267" name="Straight Arrow Connector 266">
+            <a:extLst>
+              <a:ext uri="{FF2B5EF4-FFF2-40B4-BE49-F238E27FC236}">
+                <a16:creationId xmlns:a16="http://schemas.microsoft.com/office/drawing/2014/main" id="{72FD8699-BCE9-2576-AD88-1BB542BEA990}"/>
+              </a:ext>
+            </a:extLst>
+          </p:cNvPr>
+          <p:cNvCxnSpPr>
+            <a:cxnSpLocks/>
+          </p:cNvCxnSpPr>
+          <p:nvPr/>
+        </p:nvCxnSpPr>
+        <p:spPr>
+          <a:xfrm>
+            <a:off x="2948518" y="4605789"/>
+            <a:ext cx="1522" cy="462646"/>
+          </a:xfrm>
+          <a:prstGeom prst="straightConnector1">
+            <a:avLst/>
+          </a:prstGeom>
+          <a:ln>
+            <a:solidFill>
+              <a:srgbClr val="7030A0"/>
+            </a:solidFill>
+            <a:tailEnd type="triangle"/>
+          </a:ln>
+        </p:spPr>
+        <p:style>
+          <a:lnRef idx="2">
+            <a:schemeClr val="accent1"/>
+          </a:lnRef>
+          <a:fillRef idx="0">
+            <a:schemeClr val="accent1"/>
+          </a:fillRef>
+          <a:effectRef idx="1">
+            <a:schemeClr val="accent1"/>
+          </a:effectRef>
+          <a:fontRef idx="minor">
+            <a:schemeClr val="tx1"/>
+          </a:fontRef>
+        </p:style>
+      </p:cxnSp>
+      <p:cxnSp>
+        <p:nvCxnSpPr>
+          <p:cNvPr id="270" name="Straight Connector 269">
+            <a:extLst>
+              <a:ext uri="{FF2B5EF4-FFF2-40B4-BE49-F238E27FC236}">
+                <a16:creationId xmlns:a16="http://schemas.microsoft.com/office/drawing/2014/main" id="{1F31B8BE-D5F1-6BB2-882B-3F8DA224F6D2}"/>
+              </a:ext>
+            </a:extLst>
+          </p:cNvPr>
+          <p:cNvCxnSpPr>
+            <a:cxnSpLocks/>
+          </p:cNvCxnSpPr>
+          <p:nvPr/>
+        </p:nvCxnSpPr>
+        <p:spPr>
+          <a:xfrm flipH="1">
+            <a:off x="2951753" y="4961621"/>
+            <a:ext cx="97061" cy="0"/>
+          </a:xfrm>
+          <a:prstGeom prst="line">
+            <a:avLst/>
+          </a:prstGeom>
+          <a:ln>
+            <a:solidFill>
+              <a:srgbClr val="7030A0"/>
+            </a:solidFill>
+          </a:ln>
+        </p:spPr>
+        <p:style>
+          <a:lnRef idx="2">
+            <a:schemeClr val="accent1"/>
+          </a:lnRef>
+          <a:fillRef idx="0">
+            <a:schemeClr val="accent1"/>
+          </a:fillRef>
+          <a:effectRef idx="1">
+            <a:schemeClr val="accent1"/>
+          </a:effectRef>
+          <a:fontRef idx="minor">
+            <a:schemeClr val="tx1"/>
+          </a:fontRef>
+        </p:style>
+      </p:cxnSp>
+      <p:cxnSp>
+        <p:nvCxnSpPr>
+          <p:cNvPr id="272" name="Straight Connector 271">
+            <a:extLst>
+              <a:ext uri="{FF2B5EF4-FFF2-40B4-BE49-F238E27FC236}">
+                <a16:creationId xmlns:a16="http://schemas.microsoft.com/office/drawing/2014/main" id="{12E6660C-ADF1-F621-AF4D-3FF0083BBF14}"/>
+              </a:ext>
+            </a:extLst>
+          </p:cNvPr>
+          <p:cNvCxnSpPr>
+            <a:cxnSpLocks/>
+          </p:cNvCxnSpPr>
+          <p:nvPr/>
+        </p:nvCxnSpPr>
+        <p:spPr>
+          <a:xfrm flipH="1">
+            <a:off x="2950123" y="4614107"/>
+            <a:ext cx="97061" cy="0"/>
+          </a:xfrm>
+          <a:prstGeom prst="line">
+            <a:avLst/>
+          </a:prstGeom>
+          <a:ln>
+            <a:solidFill>
+              <a:srgbClr val="7030A0"/>
+            </a:solidFill>
+          </a:ln>
+        </p:spPr>
+        <p:style>
+          <a:lnRef idx="2">
+            <a:schemeClr val="accent1"/>
+          </a:lnRef>
+          <a:fillRef idx="0">
+            <a:schemeClr val="accent1"/>
+          </a:fillRef>
+          <a:effectRef idx="1">
+            <a:schemeClr val="accent1"/>
+          </a:effectRef>
+          <a:fontRef idx="minor">
+            <a:schemeClr val="tx1"/>
+          </a:fontRef>
+        </p:style>
+      </p:cxnSp>
+      <p:cxnSp>
+        <p:nvCxnSpPr>
+          <p:cNvPr id="273" name="Straight Connector 272">
+            <a:extLst>
+              <a:ext uri="{FF2B5EF4-FFF2-40B4-BE49-F238E27FC236}">
+                <a16:creationId xmlns:a16="http://schemas.microsoft.com/office/drawing/2014/main" id="{18E9B18F-F8F6-4DA6-E928-C98A85A8B2F3}"/>
+              </a:ext>
+            </a:extLst>
+          </p:cNvPr>
+          <p:cNvCxnSpPr>
+            <a:cxnSpLocks/>
+          </p:cNvCxnSpPr>
+          <p:nvPr/>
+        </p:nvCxnSpPr>
+        <p:spPr>
+          <a:xfrm flipH="1">
+            <a:off x="2952568" y="4725279"/>
+            <a:ext cx="97061" cy="0"/>
+          </a:xfrm>
+          <a:prstGeom prst="line">
+            <a:avLst/>
+          </a:prstGeom>
+          <a:ln>
+            <a:solidFill>
+              <a:srgbClr val="7030A0"/>
+            </a:solidFill>
+          </a:ln>
+        </p:spPr>
+        <p:style>
+          <a:lnRef idx="2">
+            <a:schemeClr val="accent1"/>
+          </a:lnRef>
+          <a:fillRef idx="0">
+            <a:schemeClr val="accent1"/>
+          </a:fillRef>
+          <a:effectRef idx="1">
+            <a:schemeClr val="accent1"/>
+          </a:effectRef>
+          <a:fontRef idx="minor">
+            <a:schemeClr val="tx1"/>
+          </a:fontRef>
+        </p:style>
+      </p:cxnSp>
+      <p:cxnSp>
+        <p:nvCxnSpPr>
+          <p:cNvPr id="274" name="Straight Connector 273">
+            <a:extLst>
+              <a:ext uri="{FF2B5EF4-FFF2-40B4-BE49-F238E27FC236}">
+                <a16:creationId xmlns:a16="http://schemas.microsoft.com/office/drawing/2014/main" id="{D5E7CC13-6407-8A44-0856-712501757557}"/>
+              </a:ext>
+            </a:extLst>
+          </p:cNvPr>
+          <p:cNvCxnSpPr>
+            <a:cxnSpLocks/>
+          </p:cNvCxnSpPr>
+          <p:nvPr/>
+        </p:nvCxnSpPr>
+        <p:spPr>
+          <a:xfrm flipH="1">
+            <a:off x="2955013" y="4852415"/>
+            <a:ext cx="97061" cy="0"/>
+          </a:xfrm>
+          <a:prstGeom prst="line">
+            <a:avLst/>
+          </a:prstGeom>
+          <a:ln>
+            <a:solidFill>
+              <a:srgbClr val="7030A0"/>
+            </a:solidFill>
+          </a:ln>
+        </p:spPr>
+        <p:style>
+          <a:lnRef idx="2">
+            <a:schemeClr val="accent1"/>
+          </a:lnRef>
+          <a:fillRef idx="0">
+            <a:schemeClr val="accent1"/>
+          </a:fillRef>
+          <a:effectRef idx="1">
+            <a:schemeClr val="accent1"/>
+          </a:effectRef>
+          <a:fontRef idx="minor">
+            <a:schemeClr val="tx1"/>
+          </a:fontRef>
+        </p:style>
+      </p:cxnSp>
+      <p:sp>
+        <p:nvSpPr>
+          <p:cNvPr id="275" name="TextBox 274">
+            <a:extLst>
+              <a:ext uri="{FF2B5EF4-FFF2-40B4-BE49-F238E27FC236}">
+                <a16:creationId xmlns:a16="http://schemas.microsoft.com/office/drawing/2014/main" id="{470E2C1D-D4B7-28AF-2E3B-26036272B007}"/>
+              </a:ext>
+            </a:extLst>
+          </p:cNvPr>
+          <p:cNvSpPr txBox="1"/>
+          <p:nvPr/>
+        </p:nvSpPr>
+        <p:spPr>
+          <a:xfrm>
+            <a:off x="2870574" y="4502246"/>
+            <a:ext cx="861489" cy="215444"/>
+          </a:xfrm>
+          <a:prstGeom prst="rect">
+            <a:avLst/>
+          </a:prstGeom>
+          <a:noFill/>
+        </p:spPr>
+        <p:txBody>
+          <a:bodyPr wrap="square" rtlCol="0">
+            <a:spAutoFit/>
+          </a:bodyPr>
+          <a:lstStyle/>
+          <a:p>
+            <a:pPr algn="ctr"/>
+            <a:r>
+              <a:rPr lang="en-US" sz="800" dirty="0" err="1">
+                <a:solidFill>
+                  <a:srgbClr val="7030A0"/>
+                </a:solidFill>
+              </a:rPr>
+              <a:t>if_id_instr</a:t>
+            </a:r>
+            <a:endParaRPr lang="en-US" sz="800" dirty="0">
+              <a:solidFill>
+                <a:srgbClr val="7030A0"/>
+              </a:solidFill>
+            </a:endParaRPr>
+          </a:p>
+        </p:txBody>
+      </p:sp>
+      <p:sp>
+        <p:nvSpPr>
+          <p:cNvPr id="276" name="TextBox 275">
+            <a:extLst>
+              <a:ext uri="{FF2B5EF4-FFF2-40B4-BE49-F238E27FC236}">
+                <a16:creationId xmlns:a16="http://schemas.microsoft.com/office/drawing/2014/main" id="{E2B8B7CF-D50B-10C2-F715-A44A61910584}"/>
+              </a:ext>
+            </a:extLst>
+          </p:cNvPr>
+          <p:cNvSpPr txBox="1"/>
+          <p:nvPr/>
+        </p:nvSpPr>
+        <p:spPr>
+          <a:xfrm>
+            <a:off x="2669025" y="5741342"/>
+            <a:ext cx="861489" cy="215444"/>
+          </a:xfrm>
+          <a:prstGeom prst="rect">
+            <a:avLst/>
+          </a:prstGeom>
+          <a:noFill/>
+        </p:spPr>
+        <p:txBody>
+          <a:bodyPr wrap="square" rtlCol="0">
+            <a:spAutoFit/>
+          </a:bodyPr>
+          <a:lstStyle/>
+          <a:p>
+            <a:pPr algn="ctr"/>
+            <a:r>
+              <a:rPr lang="en-US" sz="800" dirty="0" err="1">
+                <a:solidFill>
+                  <a:srgbClr val="7030A0"/>
+                </a:solidFill>
+              </a:rPr>
+              <a:t>instr</a:t>
+            </a:r>
+            <a:endParaRPr lang="en-US" sz="800" dirty="0">
+              <a:solidFill>
+                <a:srgbClr val="7030A0"/>
+              </a:solidFill>
+            </a:endParaRPr>
+          </a:p>
+        </p:txBody>
+      </p:sp>
+      <p:sp>
+        <p:nvSpPr>
+          <p:cNvPr id="277" name="TextBox 276">
+            <a:extLst>
+              <a:ext uri="{FF2B5EF4-FFF2-40B4-BE49-F238E27FC236}">
+                <a16:creationId xmlns:a16="http://schemas.microsoft.com/office/drawing/2014/main" id="{C5C8E779-5B4E-38C9-AD5F-3F44DF373B84}"/>
+              </a:ext>
+            </a:extLst>
+          </p:cNvPr>
+          <p:cNvSpPr txBox="1"/>
+          <p:nvPr/>
+        </p:nvSpPr>
+        <p:spPr>
+          <a:xfrm>
+            <a:off x="2813244" y="4616163"/>
+            <a:ext cx="861489" cy="215444"/>
+          </a:xfrm>
+          <a:prstGeom prst="rect">
+            <a:avLst/>
+          </a:prstGeom>
+          <a:noFill/>
+        </p:spPr>
+        <p:txBody>
+          <a:bodyPr wrap="square" rtlCol="0">
+            <a:spAutoFit/>
+          </a:bodyPr>
+          <a:lstStyle/>
+          <a:p>
+            <a:pPr algn="ctr"/>
+            <a:r>
+              <a:rPr lang="en-US" sz="800" dirty="0">
+                <a:solidFill>
+                  <a:srgbClr val="7030A0"/>
+                </a:solidFill>
+              </a:rPr>
+              <a:t>branch</a:t>
+            </a:r>
+          </a:p>
+        </p:txBody>
+      </p:sp>
+      <p:sp>
+        <p:nvSpPr>
+          <p:cNvPr id="278" name="TextBox 277">
+            <a:extLst>
+              <a:ext uri="{FF2B5EF4-FFF2-40B4-BE49-F238E27FC236}">
+                <a16:creationId xmlns:a16="http://schemas.microsoft.com/office/drawing/2014/main" id="{6564928D-CC06-6F2F-74F4-B507BE3CC7D1}"/>
+              </a:ext>
+            </a:extLst>
+          </p:cNvPr>
+          <p:cNvSpPr txBox="1"/>
+          <p:nvPr/>
+        </p:nvSpPr>
+        <p:spPr>
+          <a:xfrm>
+            <a:off x="2769274" y="4746729"/>
+            <a:ext cx="861489" cy="215444"/>
+          </a:xfrm>
+          <a:prstGeom prst="rect">
+            <a:avLst/>
+          </a:prstGeom>
+          <a:noFill/>
+        </p:spPr>
+        <p:txBody>
+          <a:bodyPr wrap="square" rtlCol="0">
+            <a:spAutoFit/>
+          </a:bodyPr>
+          <a:lstStyle/>
+          <a:p>
+            <a:pPr algn="ctr"/>
+            <a:r>
+              <a:rPr lang="en-US" sz="800" dirty="0">
+                <a:solidFill>
+                  <a:srgbClr val="7030A0"/>
+                </a:solidFill>
+              </a:rPr>
+              <a:t>jump</a:t>
+            </a:r>
+          </a:p>
+        </p:txBody>
+      </p:sp>
+      <p:sp>
+        <p:nvSpPr>
+          <p:cNvPr id="279" name="TextBox 278">
+            <a:extLst>
+              <a:ext uri="{FF2B5EF4-FFF2-40B4-BE49-F238E27FC236}">
+                <a16:creationId xmlns:a16="http://schemas.microsoft.com/office/drawing/2014/main" id="{A06084C7-26BD-1CB9-74A4-2FDA84CB08D3}"/>
+              </a:ext>
+            </a:extLst>
+          </p:cNvPr>
+          <p:cNvSpPr txBox="1"/>
+          <p:nvPr/>
+        </p:nvSpPr>
+        <p:spPr>
+          <a:xfrm>
+            <a:off x="2763366" y="4859985"/>
+            <a:ext cx="861489" cy="215444"/>
+          </a:xfrm>
+          <a:prstGeom prst="rect">
+            <a:avLst/>
+          </a:prstGeom>
+          <a:noFill/>
+        </p:spPr>
+        <p:txBody>
+          <a:bodyPr wrap="square" rtlCol="0">
+            <a:spAutoFit/>
+          </a:bodyPr>
+          <a:lstStyle/>
+          <a:p>
+            <a:pPr algn="ctr"/>
+            <a:r>
+              <a:rPr lang="en-US" sz="800" dirty="0">
+                <a:solidFill>
+                  <a:srgbClr val="7030A0"/>
+                </a:solidFill>
+              </a:rPr>
+              <a:t>reset</a:t>
+            </a:r>
+          </a:p>
+        </p:txBody>
+      </p:sp>
+      <p:cxnSp>
+        <p:nvCxnSpPr>
+          <p:cNvPr id="280" name="Straight Connector 279">
+            <a:extLst>
+              <a:ext uri="{FF2B5EF4-FFF2-40B4-BE49-F238E27FC236}">
+                <a16:creationId xmlns:a16="http://schemas.microsoft.com/office/drawing/2014/main" id="{80C41FA1-7628-C4B5-548D-96C20932F817}"/>
+              </a:ext>
+            </a:extLst>
+          </p:cNvPr>
+          <p:cNvCxnSpPr>
+            <a:cxnSpLocks/>
+          </p:cNvCxnSpPr>
+          <p:nvPr/>
+        </p:nvCxnSpPr>
+        <p:spPr>
+          <a:xfrm>
+            <a:off x="3373159" y="4264982"/>
+            <a:ext cx="0" cy="172547"/>
+          </a:xfrm>
+          <a:prstGeom prst="line">
+            <a:avLst/>
+          </a:prstGeom>
+          <a:ln>
+            <a:solidFill>
+              <a:srgbClr val="7030A0"/>
+            </a:solidFill>
+          </a:ln>
+        </p:spPr>
+        <p:style>
+          <a:lnRef idx="2">
+            <a:schemeClr val="accent1"/>
+          </a:lnRef>
+          <a:fillRef idx="0">
+            <a:schemeClr val="accent1"/>
+          </a:fillRef>
+          <a:effectRef idx="1">
+            <a:schemeClr val="accent1"/>
+          </a:effectRef>
+          <a:fontRef idx="minor">
+            <a:schemeClr val="tx1"/>
+          </a:fontRef>
+        </p:style>
+      </p:cxnSp>
+      <p:sp>
+        <p:nvSpPr>
+          <p:cNvPr id="282" name="TextBox 281">
+            <a:extLst>
+              <a:ext uri="{FF2B5EF4-FFF2-40B4-BE49-F238E27FC236}">
+                <a16:creationId xmlns:a16="http://schemas.microsoft.com/office/drawing/2014/main" id="{3664F9D8-BBDF-45CE-51C5-BD5626068EF2}"/>
+              </a:ext>
+            </a:extLst>
+          </p:cNvPr>
+          <p:cNvSpPr txBox="1"/>
+          <p:nvPr/>
+        </p:nvSpPr>
+        <p:spPr>
+          <a:xfrm>
+            <a:off x="3233866" y="4320082"/>
+            <a:ext cx="1216757" cy="215444"/>
+          </a:xfrm>
+          <a:prstGeom prst="rect">
+            <a:avLst/>
+          </a:prstGeom>
+          <a:noFill/>
+        </p:spPr>
+        <p:txBody>
+          <a:bodyPr wrap="square" rtlCol="0">
+            <a:spAutoFit/>
+          </a:bodyPr>
+          <a:lstStyle/>
+          <a:p>
+            <a:pPr algn="ctr"/>
+            <a:r>
+              <a:rPr lang="en-US" sz="800" dirty="0" err="1">
+                <a:solidFill>
+                  <a:srgbClr val="7030A0"/>
+                </a:solidFill>
+              </a:rPr>
+              <a:t>mem_wb_reg_write</a:t>
+            </a:r>
+            <a:endParaRPr lang="en-US" sz="800" dirty="0">
+              <a:solidFill>
+                <a:srgbClr val="7030A0"/>
+              </a:solidFill>
+            </a:endParaRPr>
+          </a:p>
+        </p:txBody>
+      </p:sp>
+      <p:sp>
+        <p:nvSpPr>
+          <p:cNvPr id="283" name="TextBox 282">
+            <a:extLst>
+              <a:ext uri="{FF2B5EF4-FFF2-40B4-BE49-F238E27FC236}">
+                <a16:creationId xmlns:a16="http://schemas.microsoft.com/office/drawing/2014/main" id="{AA3E0DA0-37B7-DE13-DBA1-E17009FF4E8D}"/>
+              </a:ext>
+            </a:extLst>
+          </p:cNvPr>
+          <p:cNvSpPr txBox="1"/>
+          <p:nvPr/>
+        </p:nvSpPr>
+        <p:spPr>
+          <a:xfrm>
+            <a:off x="3983668" y="1846164"/>
+            <a:ext cx="918842" cy="230832"/>
+          </a:xfrm>
+          <a:prstGeom prst="rect">
+            <a:avLst/>
+          </a:prstGeom>
+          <a:noFill/>
+        </p:spPr>
+        <p:txBody>
+          <a:bodyPr wrap="none" rtlCol="0">
+            <a:spAutoFit/>
+          </a:bodyPr>
+          <a:lstStyle/>
+          <a:p>
+            <a:pPr algn="ctr"/>
+            <a:r>
+              <a:rPr lang="en-US" sz="900" dirty="0" err="1">
+                <a:solidFill>
+                  <a:srgbClr val="7030A0"/>
+                </a:solidFill>
+              </a:rPr>
+              <a:t>not_equal_flag</a:t>
+            </a:r>
+            <a:endParaRPr lang="en-US" sz="900" dirty="0">
+              <a:solidFill>
+                <a:srgbClr val="7030A0"/>
+              </a:solidFill>
+            </a:endParaRPr>
+          </a:p>
+        </p:txBody>
+      </p:sp>
+      <p:cxnSp>
+        <p:nvCxnSpPr>
+          <p:cNvPr id="284" name="Straight Connector 283">
+            <a:extLst>
+              <a:ext uri="{FF2B5EF4-FFF2-40B4-BE49-F238E27FC236}">
+                <a16:creationId xmlns:a16="http://schemas.microsoft.com/office/drawing/2014/main" id="{896814D2-BE70-79B8-A702-880D8B926364}"/>
+              </a:ext>
+            </a:extLst>
+          </p:cNvPr>
+          <p:cNvCxnSpPr>
+            <a:cxnSpLocks/>
+          </p:cNvCxnSpPr>
+          <p:nvPr/>
+        </p:nvCxnSpPr>
+        <p:spPr>
+          <a:xfrm flipH="1">
+            <a:off x="2933904" y="1286028"/>
+            <a:ext cx="1743228" cy="0"/>
+          </a:xfrm>
+          <a:prstGeom prst="line">
+            <a:avLst/>
+          </a:prstGeom>
+          <a:ln>
+            <a:solidFill>
+              <a:srgbClr val="7030A0"/>
+            </a:solidFill>
+          </a:ln>
+        </p:spPr>
+        <p:style>
+          <a:lnRef idx="2">
+            <a:schemeClr val="accent1"/>
+          </a:lnRef>
+          <a:fillRef idx="0">
+            <a:schemeClr val="accent1"/>
+          </a:fillRef>
+          <a:effectRef idx="1">
+            <a:schemeClr val="accent1"/>
+          </a:effectRef>
+          <a:fontRef idx="minor">
+            <a:schemeClr val="tx1"/>
+          </a:fontRef>
+        </p:style>
+      </p:cxnSp>
+      <p:cxnSp>
+        <p:nvCxnSpPr>
+          <p:cNvPr id="66" name="Straight Connector 65">
+            <a:extLst>
+              <a:ext uri="{FF2B5EF4-FFF2-40B4-BE49-F238E27FC236}">
+                <a16:creationId xmlns:a16="http://schemas.microsoft.com/office/drawing/2014/main" id="{6FB6B444-B674-9C03-9DC1-95AC81563780}"/>
+              </a:ext>
+            </a:extLst>
+          </p:cNvPr>
+          <p:cNvCxnSpPr>
+            <a:cxnSpLocks/>
+          </p:cNvCxnSpPr>
+          <p:nvPr/>
+        </p:nvCxnSpPr>
+        <p:spPr>
+          <a:xfrm>
+            <a:off x="2943683" y="1288473"/>
+            <a:ext cx="0" cy="667463"/>
+          </a:xfrm>
+          <a:prstGeom prst="line">
+            <a:avLst/>
+          </a:prstGeom>
+          <a:ln>
+            <a:solidFill>
+              <a:srgbClr val="7030A0"/>
+            </a:solidFill>
+          </a:ln>
+        </p:spPr>
+        <p:style>
+          <a:lnRef idx="2">
+            <a:schemeClr val="accent1"/>
+          </a:lnRef>
+          <a:fillRef idx="0">
+            <a:schemeClr val="accent1"/>
+          </a:fillRef>
+          <a:effectRef idx="1">
+            <a:schemeClr val="accent1"/>
+          </a:effectRef>
+          <a:fontRef idx="minor">
+            <a:schemeClr val="tx1"/>
+          </a:fontRef>
+        </p:style>
+      </p:cxnSp>
+      <p:cxnSp>
+        <p:nvCxnSpPr>
+          <p:cNvPr id="76" name="Straight Connector 75">
+            <a:extLst>
+              <a:ext uri="{FF2B5EF4-FFF2-40B4-BE49-F238E27FC236}">
+                <a16:creationId xmlns:a16="http://schemas.microsoft.com/office/drawing/2014/main" id="{38872745-403A-D61E-690B-98BB21981EC5}"/>
+              </a:ext>
+            </a:extLst>
+          </p:cNvPr>
+          <p:cNvCxnSpPr>
+            <a:cxnSpLocks/>
+          </p:cNvCxnSpPr>
+          <p:nvPr/>
+        </p:nvCxnSpPr>
+        <p:spPr>
+          <a:xfrm flipH="1">
+            <a:off x="2759149" y="1944527"/>
+            <a:ext cx="196759" cy="0"/>
+          </a:xfrm>
+          <a:prstGeom prst="line">
+            <a:avLst/>
+          </a:prstGeom>
+          <a:ln>
+            <a:solidFill>
+              <a:srgbClr val="7030A0"/>
+            </a:solidFill>
+          </a:ln>
+        </p:spPr>
+        <p:style>
+          <a:lnRef idx="2">
+            <a:schemeClr val="accent1"/>
+          </a:lnRef>
+          <a:fillRef idx="0">
+            <a:schemeClr val="accent1"/>
+          </a:fillRef>
+          <a:effectRef idx="1">
+            <a:schemeClr val="accent1"/>
+          </a:effectRef>
+          <a:fontRef idx="minor">
+            <a:schemeClr val="tx1"/>
+          </a:fontRef>
+        </p:style>
+      </p:cxnSp>
+      <p:cxnSp>
+        <p:nvCxnSpPr>
+          <p:cNvPr id="78" name="Straight Connector 77">
+            <a:extLst>
+              <a:ext uri="{FF2B5EF4-FFF2-40B4-BE49-F238E27FC236}">
+                <a16:creationId xmlns:a16="http://schemas.microsoft.com/office/drawing/2014/main" id="{1D180000-0F86-9CC5-F9B6-1169BF64D4CC}"/>
+              </a:ext>
+            </a:extLst>
+          </p:cNvPr>
+          <p:cNvCxnSpPr>
+            <a:cxnSpLocks/>
+          </p:cNvCxnSpPr>
+          <p:nvPr/>
+        </p:nvCxnSpPr>
+        <p:spPr>
+          <a:xfrm flipH="1">
+            <a:off x="5029828" y="1286843"/>
+            <a:ext cx="2100282" cy="0"/>
+          </a:xfrm>
+          <a:prstGeom prst="line">
+            <a:avLst/>
+          </a:prstGeom>
+          <a:ln>
+            <a:solidFill>
+              <a:srgbClr val="7030A0"/>
+            </a:solidFill>
+          </a:ln>
+        </p:spPr>
+        <p:style>
+          <a:lnRef idx="2">
+            <a:schemeClr val="accent1"/>
+          </a:lnRef>
+          <a:fillRef idx="0">
+            <a:schemeClr val="accent1"/>
+          </a:fillRef>
+          <a:effectRef idx="1">
+            <a:schemeClr val="accent1"/>
+          </a:effectRef>
+          <a:fontRef idx="minor">
+            <a:schemeClr val="tx1"/>
+          </a:fontRef>
+        </p:style>
+      </p:cxnSp>
+      <p:cxnSp>
+        <p:nvCxnSpPr>
+          <p:cNvPr id="80" name="Straight Connector 79">
+            <a:extLst>
+              <a:ext uri="{FF2B5EF4-FFF2-40B4-BE49-F238E27FC236}">
+                <a16:creationId xmlns:a16="http://schemas.microsoft.com/office/drawing/2014/main" id="{3E35AF76-95D9-8338-48CA-22B0D462DE4C}"/>
+              </a:ext>
+            </a:extLst>
+          </p:cNvPr>
+          <p:cNvCxnSpPr>
+            <a:cxnSpLocks/>
+          </p:cNvCxnSpPr>
+          <p:nvPr/>
+        </p:nvCxnSpPr>
+        <p:spPr>
+          <a:xfrm>
+            <a:off x="7121822" y="1295630"/>
+            <a:ext cx="0" cy="681435"/>
+          </a:xfrm>
+          <a:prstGeom prst="line">
+            <a:avLst/>
+          </a:prstGeom>
+          <a:ln>
+            <a:solidFill>
+              <a:srgbClr val="7030A0"/>
+            </a:solidFill>
+          </a:ln>
+        </p:spPr>
+        <p:style>
+          <a:lnRef idx="2">
+            <a:schemeClr val="accent1"/>
+          </a:lnRef>
+          <a:fillRef idx="0">
+            <a:schemeClr val="accent1"/>
+          </a:fillRef>
+          <a:effectRef idx="1">
+            <a:schemeClr val="accent1"/>
+          </a:effectRef>
+          <a:fontRef idx="minor">
+            <a:schemeClr val="tx1"/>
+          </a:fontRef>
+        </p:style>
+      </p:cxnSp>
+      <p:cxnSp>
+        <p:nvCxnSpPr>
+          <p:cNvPr id="88" name="Straight Connector 87">
+            <a:extLst>
+              <a:ext uri="{FF2B5EF4-FFF2-40B4-BE49-F238E27FC236}">
+                <a16:creationId xmlns:a16="http://schemas.microsoft.com/office/drawing/2014/main" id="{0F342BA5-1BE2-9DA9-D100-9AD36D0C86FB}"/>
+              </a:ext>
+            </a:extLst>
+          </p:cNvPr>
+          <p:cNvCxnSpPr>
+            <a:cxnSpLocks/>
+          </p:cNvCxnSpPr>
+          <p:nvPr/>
+        </p:nvCxnSpPr>
+        <p:spPr>
+          <a:xfrm>
+            <a:off x="7127347" y="1980740"/>
+            <a:ext cx="350214" cy="0"/>
+          </a:xfrm>
+          <a:prstGeom prst="line">
+            <a:avLst/>
+          </a:prstGeom>
+          <a:ln>
+            <a:solidFill>
+              <a:srgbClr val="7030A0"/>
+            </a:solidFill>
+          </a:ln>
+        </p:spPr>
+        <p:style>
+          <a:lnRef idx="2">
+            <a:schemeClr val="accent1"/>
+          </a:lnRef>
+          <a:fillRef idx="0">
+            <a:schemeClr val="accent1"/>
+          </a:fillRef>
+          <a:effectRef idx="1">
+            <a:schemeClr val="accent1"/>
+          </a:effectRef>
+          <a:fontRef idx="minor">
+            <a:schemeClr val="tx1"/>
+          </a:fontRef>
+        </p:style>
+      </p:cxnSp>
+      <p:cxnSp>
+        <p:nvCxnSpPr>
+          <p:cNvPr id="294" name="Straight Connector 293">
+            <a:extLst>
+              <a:ext uri="{FF2B5EF4-FFF2-40B4-BE49-F238E27FC236}">
+                <a16:creationId xmlns:a16="http://schemas.microsoft.com/office/drawing/2014/main" id="{C774F03D-0D66-164E-D9CD-9FDFA2AA4A73}"/>
+              </a:ext>
+            </a:extLst>
+          </p:cNvPr>
+          <p:cNvCxnSpPr>
+            <a:cxnSpLocks/>
+          </p:cNvCxnSpPr>
+          <p:nvPr/>
+        </p:nvCxnSpPr>
+        <p:spPr>
+          <a:xfrm flipH="1">
+            <a:off x="2747802" y="3043086"/>
+            <a:ext cx="2137233" cy="0"/>
+          </a:xfrm>
+          <a:prstGeom prst="line">
+            <a:avLst/>
+          </a:prstGeom>
+          <a:ln>
+            <a:solidFill>
+              <a:srgbClr val="7030A0"/>
+            </a:solidFill>
+          </a:ln>
+        </p:spPr>
+        <p:style>
+          <a:lnRef idx="2">
+            <a:schemeClr val="accent1"/>
+          </a:lnRef>
+          <a:fillRef idx="0">
+            <a:schemeClr val="accent1"/>
+          </a:fillRef>
+          <a:effectRef idx="1">
+            <a:schemeClr val="accent1"/>
+          </a:effectRef>
+          <a:fontRef idx="minor">
+            <a:schemeClr val="tx1"/>
+          </a:fontRef>
+        </p:style>
+      </p:cxnSp>
+      <p:sp>
+        <p:nvSpPr>
+          <p:cNvPr id="305" name="TextBox 304">
+            <a:extLst>
+              <a:ext uri="{FF2B5EF4-FFF2-40B4-BE49-F238E27FC236}">
+                <a16:creationId xmlns:a16="http://schemas.microsoft.com/office/drawing/2014/main" id="{FE9310CD-36C8-647B-0ADF-A92A0DAB2DB9}"/>
+              </a:ext>
+            </a:extLst>
+          </p:cNvPr>
+          <p:cNvSpPr txBox="1"/>
+          <p:nvPr/>
+        </p:nvSpPr>
+        <p:spPr>
+          <a:xfrm>
+            <a:off x="3187319" y="2593090"/>
+            <a:ext cx="793807" cy="461665"/>
+          </a:xfrm>
+          <a:prstGeom prst="rect">
+            <a:avLst/>
+          </a:prstGeom>
+          <a:noFill/>
+        </p:spPr>
+        <p:txBody>
+          <a:bodyPr wrap="none" rtlCol="0">
+            <a:spAutoFit/>
+          </a:bodyPr>
+          <a:lstStyle/>
+          <a:p>
+            <a:pPr marL="171450" indent="-171450" algn="ctr">
+              <a:buFont typeface="Arial" panose="020B0604020202020204" pitchFamily="34" charset="0"/>
+              <a:buChar char="•"/>
+            </a:pPr>
+            <a:r>
+              <a:rPr lang="en-US" sz="600" dirty="0" err="1">
+                <a:solidFill>
+                  <a:srgbClr val="7030A0"/>
+                </a:solidFill>
+              </a:rPr>
+              <a:t>if_id_branch</a:t>
+            </a:r>
+            <a:endParaRPr lang="en-US" sz="600" dirty="0">
+              <a:solidFill>
+                <a:srgbClr val="7030A0"/>
+              </a:solidFill>
+            </a:endParaRPr>
+          </a:p>
+          <a:p>
+            <a:pPr marL="171450" indent="-171450" algn="ctr">
+              <a:buFont typeface="Arial" panose="020B0604020202020204" pitchFamily="34" charset="0"/>
+              <a:buChar char="•"/>
+            </a:pPr>
+            <a:r>
+              <a:rPr lang="en-US" sz="600" dirty="0" err="1">
+                <a:solidFill>
+                  <a:srgbClr val="7030A0"/>
+                </a:solidFill>
+              </a:rPr>
+              <a:t>if_id_jump</a:t>
+            </a:r>
+            <a:endParaRPr lang="en-US" sz="600" dirty="0">
+              <a:solidFill>
+                <a:srgbClr val="7030A0"/>
+              </a:solidFill>
+            </a:endParaRPr>
+          </a:p>
+          <a:p>
+            <a:pPr marL="171450" indent="-171450" algn="ctr">
+              <a:buFont typeface="Arial" panose="020B0604020202020204" pitchFamily="34" charset="0"/>
+              <a:buChar char="•"/>
+            </a:pPr>
+            <a:r>
+              <a:rPr lang="en-US" sz="600" dirty="0" err="1">
+                <a:solidFill>
+                  <a:srgbClr val="7030A0"/>
+                </a:solidFill>
+              </a:rPr>
+              <a:t>start_stall</a:t>
+            </a:r>
+            <a:endParaRPr lang="en-US" sz="600" dirty="0">
+              <a:solidFill>
+                <a:srgbClr val="7030A0"/>
+              </a:solidFill>
+            </a:endParaRPr>
+          </a:p>
+          <a:p>
+            <a:pPr marL="171450" indent="-171450" algn="ctr">
+              <a:buFont typeface="Arial" panose="020B0604020202020204" pitchFamily="34" charset="0"/>
+              <a:buChar char="•"/>
+            </a:pPr>
+            <a:r>
+              <a:rPr lang="en-US" sz="600" dirty="0" err="1">
+                <a:solidFill>
+                  <a:srgbClr val="7030A0"/>
+                </a:solidFill>
+              </a:rPr>
+              <a:t>stall_counter</a:t>
+            </a:r>
+            <a:endParaRPr lang="en-US" sz="600" dirty="0">
+              <a:solidFill>
+                <a:srgbClr val="7030A0"/>
+              </a:solidFill>
+            </a:endParaRPr>
+          </a:p>
+        </p:txBody>
+      </p:sp>
+      <p:cxnSp>
+        <p:nvCxnSpPr>
+          <p:cNvPr id="312" name="Straight Connector 311">
+            <a:extLst>
+              <a:ext uri="{FF2B5EF4-FFF2-40B4-BE49-F238E27FC236}">
+                <a16:creationId xmlns:a16="http://schemas.microsoft.com/office/drawing/2014/main" id="{39E94913-24C7-A5BF-E8E6-64FDEE00617E}"/>
+              </a:ext>
+            </a:extLst>
+          </p:cNvPr>
+          <p:cNvCxnSpPr>
+            <a:cxnSpLocks/>
+          </p:cNvCxnSpPr>
+          <p:nvPr/>
+        </p:nvCxnSpPr>
+        <p:spPr>
+          <a:xfrm flipH="1">
+            <a:off x="4050231" y="2985905"/>
+            <a:ext cx="55713" cy="85378"/>
+          </a:xfrm>
+          <a:prstGeom prst="line">
+            <a:avLst/>
+          </a:prstGeom>
+          <a:ln>
+            <a:solidFill>
+              <a:srgbClr val="7030A0"/>
+            </a:solidFill>
+          </a:ln>
+        </p:spPr>
+        <p:style>
+          <a:lnRef idx="2">
+            <a:schemeClr val="accent1"/>
+          </a:lnRef>
+          <a:fillRef idx="0">
+            <a:schemeClr val="accent1"/>
+          </a:fillRef>
+          <a:effectRef idx="1">
+            <a:schemeClr val="accent1"/>
+          </a:effectRef>
+          <a:fontRef idx="minor">
+            <a:schemeClr val="tx1"/>
+          </a:fontRef>
+        </p:style>
+      </p:cxnSp>
+      <p:sp>
+        <p:nvSpPr>
+          <p:cNvPr id="317" name="TextBox 316">
+            <a:extLst>
+              <a:ext uri="{FF2B5EF4-FFF2-40B4-BE49-F238E27FC236}">
+                <a16:creationId xmlns:a16="http://schemas.microsoft.com/office/drawing/2014/main" id="{31435417-C1AE-639F-C031-2ABC76352227}"/>
+              </a:ext>
+            </a:extLst>
+          </p:cNvPr>
+          <p:cNvSpPr txBox="1"/>
+          <p:nvPr/>
+        </p:nvSpPr>
+        <p:spPr>
+          <a:xfrm>
+            <a:off x="3959051" y="2819739"/>
+            <a:ext cx="245580" cy="230832"/>
+          </a:xfrm>
+          <a:prstGeom prst="rect">
+            <a:avLst/>
+          </a:prstGeom>
+          <a:noFill/>
+        </p:spPr>
+        <p:txBody>
+          <a:bodyPr wrap="none" rtlCol="0">
+            <a:spAutoFit/>
+          </a:bodyPr>
+          <a:lstStyle/>
+          <a:p>
+            <a:pPr algn="ctr"/>
+            <a:r>
+              <a:rPr lang="en-US" sz="900" dirty="0">
+                <a:solidFill>
+                  <a:srgbClr val="7030A0"/>
+                </a:solidFill>
+              </a:rPr>
+              <a:t>4</a:t>
+            </a:r>
+          </a:p>
+        </p:txBody>
+      </p:sp>
+      <p:sp>
+        <p:nvSpPr>
+          <p:cNvPr id="107" name="TextBox 106">
+            <a:extLst>
+              <a:ext uri="{FF2B5EF4-FFF2-40B4-BE49-F238E27FC236}">
+                <a16:creationId xmlns:a16="http://schemas.microsoft.com/office/drawing/2014/main" id="{EE70BB9A-F87F-D53A-B0B4-67DE63937ABD}"/>
+              </a:ext>
+            </a:extLst>
+          </p:cNvPr>
+          <p:cNvSpPr txBox="1"/>
+          <p:nvPr/>
+        </p:nvSpPr>
+        <p:spPr>
+          <a:xfrm>
+            <a:off x="5927518" y="2387109"/>
+            <a:ext cx="245580" cy="230832"/>
+          </a:xfrm>
+          <a:prstGeom prst="rect">
+            <a:avLst/>
+          </a:prstGeom>
+          <a:noFill/>
+        </p:spPr>
+        <p:txBody>
+          <a:bodyPr wrap="none" rtlCol="0">
+            <a:spAutoFit/>
+          </a:bodyPr>
+          <a:lstStyle/>
+          <a:p>
+            <a:pPr algn="ctr"/>
+            <a:r>
+              <a:rPr lang="en-US" sz="900" dirty="0">
+                <a:solidFill>
+                  <a:srgbClr val="7030A0"/>
+                </a:solidFill>
+              </a:rPr>
+              <a:t>2</a:t>
+            </a:r>
+          </a:p>
+        </p:txBody>
+      </p:sp>
+      <p:sp>
+        <p:nvSpPr>
+          <p:cNvPr id="108" name="TextBox 107">
+            <a:extLst>
+              <a:ext uri="{FF2B5EF4-FFF2-40B4-BE49-F238E27FC236}">
+                <a16:creationId xmlns:a16="http://schemas.microsoft.com/office/drawing/2014/main" id="{B48FC2EA-1820-DD9A-8E78-C263092618A5}"/>
+              </a:ext>
+            </a:extLst>
+          </p:cNvPr>
+          <p:cNvSpPr txBox="1"/>
+          <p:nvPr/>
+        </p:nvSpPr>
+        <p:spPr>
+          <a:xfrm>
+            <a:off x="5569726" y="1982024"/>
+            <a:ext cx="877163" cy="230832"/>
+          </a:xfrm>
+          <a:prstGeom prst="rect">
+            <a:avLst/>
+          </a:prstGeom>
+          <a:noFill/>
+        </p:spPr>
+        <p:txBody>
+          <a:bodyPr wrap="none" rtlCol="0">
+            <a:spAutoFit/>
+          </a:bodyPr>
+          <a:lstStyle/>
+          <a:p>
+            <a:pPr algn="ctr"/>
+            <a:r>
+              <a:rPr lang="en-US" sz="900" dirty="0" err="1">
+                <a:solidFill>
+                  <a:srgbClr val="7030A0"/>
+                </a:solidFill>
+              </a:rPr>
+              <a:t>mux_select_A</a:t>
+            </a:r>
+            <a:endParaRPr lang="en-US" sz="900" dirty="0">
+              <a:solidFill>
+                <a:srgbClr val="7030A0"/>
+              </a:solidFill>
+            </a:endParaRPr>
+          </a:p>
+        </p:txBody>
+      </p:sp>
+      <p:cxnSp>
+        <p:nvCxnSpPr>
+          <p:cNvPr id="109" name="Straight Connector 108">
+            <a:extLst>
+              <a:ext uri="{FF2B5EF4-FFF2-40B4-BE49-F238E27FC236}">
+                <a16:creationId xmlns:a16="http://schemas.microsoft.com/office/drawing/2014/main" id="{2D14C76E-820A-4226-93B6-C8DF2BADE66D}"/>
+              </a:ext>
+            </a:extLst>
+          </p:cNvPr>
+          <p:cNvCxnSpPr>
+            <a:cxnSpLocks/>
+          </p:cNvCxnSpPr>
+          <p:nvPr/>
+        </p:nvCxnSpPr>
+        <p:spPr>
+          <a:xfrm flipH="1">
+            <a:off x="5548922" y="4361957"/>
+            <a:ext cx="399414" cy="0"/>
+          </a:xfrm>
+          <a:prstGeom prst="line">
+            <a:avLst/>
+          </a:prstGeom>
+          <a:ln>
+            <a:solidFill>
+              <a:srgbClr val="7030A0"/>
+            </a:solidFill>
+          </a:ln>
+        </p:spPr>
+        <p:style>
+          <a:lnRef idx="2">
+            <a:schemeClr val="accent1"/>
+          </a:lnRef>
+          <a:fillRef idx="0">
+            <a:schemeClr val="accent1"/>
+          </a:fillRef>
+          <a:effectRef idx="1">
+            <a:schemeClr val="accent1"/>
+          </a:effectRef>
+          <a:fontRef idx="minor">
+            <a:schemeClr val="tx1"/>
+          </a:fontRef>
+        </p:style>
+      </p:cxnSp>
+      <p:sp>
+        <p:nvSpPr>
+          <p:cNvPr id="320" name="TextBox 319">
+            <a:extLst>
+              <a:ext uri="{FF2B5EF4-FFF2-40B4-BE49-F238E27FC236}">
+                <a16:creationId xmlns:a16="http://schemas.microsoft.com/office/drawing/2014/main" id="{D49DD678-22A0-F8AA-A911-D129710448E6}"/>
+              </a:ext>
+            </a:extLst>
+          </p:cNvPr>
+          <p:cNvSpPr txBox="1"/>
+          <p:nvPr/>
+        </p:nvSpPr>
+        <p:spPr>
+          <a:xfrm>
+            <a:off x="5502704" y="4315883"/>
+            <a:ext cx="861134" cy="230832"/>
+          </a:xfrm>
+          <a:prstGeom prst="rect">
+            <a:avLst/>
+          </a:prstGeom>
+          <a:noFill/>
+        </p:spPr>
+        <p:txBody>
+          <a:bodyPr wrap="none" rtlCol="0">
+            <a:spAutoFit/>
+          </a:bodyPr>
+          <a:lstStyle/>
+          <a:p>
+            <a:pPr algn="ctr"/>
+            <a:r>
+              <a:rPr lang="en-US" sz="900" dirty="0" err="1">
+                <a:solidFill>
+                  <a:srgbClr val="7030A0"/>
+                </a:solidFill>
+              </a:rPr>
+              <a:t>id_ex_alu_src</a:t>
+            </a:r>
+            <a:endParaRPr lang="en-US" sz="900" dirty="0">
+              <a:solidFill>
+                <a:srgbClr val="7030A0"/>
+              </a:solidFill>
+            </a:endParaRPr>
+          </a:p>
+        </p:txBody>
+      </p:sp>
+      <p:cxnSp>
+        <p:nvCxnSpPr>
+          <p:cNvPr id="323" name="Straight Connector 322">
+            <a:extLst>
+              <a:ext uri="{FF2B5EF4-FFF2-40B4-BE49-F238E27FC236}">
+                <a16:creationId xmlns:a16="http://schemas.microsoft.com/office/drawing/2014/main" id="{816BD419-E88D-C5B4-E72D-7ECA12C9476B}"/>
+              </a:ext>
+            </a:extLst>
+          </p:cNvPr>
+          <p:cNvCxnSpPr>
+            <a:cxnSpLocks/>
+          </p:cNvCxnSpPr>
+          <p:nvPr/>
+        </p:nvCxnSpPr>
+        <p:spPr>
+          <a:xfrm flipH="1">
+            <a:off x="5541802" y="4546715"/>
+            <a:ext cx="868619" cy="8021"/>
+          </a:xfrm>
+          <a:prstGeom prst="line">
+            <a:avLst/>
+          </a:prstGeom>
+          <a:ln>
+            <a:solidFill>
+              <a:srgbClr val="7030A0"/>
+            </a:solidFill>
+          </a:ln>
+        </p:spPr>
+        <p:style>
+          <a:lnRef idx="2">
+            <a:schemeClr val="accent1"/>
+          </a:lnRef>
+          <a:fillRef idx="0">
+            <a:schemeClr val="accent1"/>
+          </a:fillRef>
+          <a:effectRef idx="1">
+            <a:schemeClr val="accent1"/>
+          </a:effectRef>
+          <a:fontRef idx="minor">
+            <a:schemeClr val="tx1"/>
+          </a:fontRef>
+        </p:style>
+      </p:cxnSp>
+      <p:sp>
+        <p:nvSpPr>
+          <p:cNvPr id="325" name="TextBox 324">
+            <a:extLst>
+              <a:ext uri="{FF2B5EF4-FFF2-40B4-BE49-F238E27FC236}">
+                <a16:creationId xmlns:a16="http://schemas.microsoft.com/office/drawing/2014/main" id="{D53F4CE1-DADB-CD4B-F736-316D872D7DC7}"/>
+              </a:ext>
+            </a:extLst>
+          </p:cNvPr>
+          <p:cNvSpPr txBox="1"/>
+          <p:nvPr/>
+        </p:nvSpPr>
+        <p:spPr>
+          <a:xfrm>
+            <a:off x="5623364" y="4508872"/>
+            <a:ext cx="830677" cy="230832"/>
+          </a:xfrm>
+          <a:prstGeom prst="rect">
+            <a:avLst/>
+          </a:prstGeom>
+          <a:noFill/>
+        </p:spPr>
+        <p:txBody>
+          <a:bodyPr wrap="none" rtlCol="0">
+            <a:spAutoFit/>
+          </a:bodyPr>
+          <a:lstStyle/>
+          <a:p>
+            <a:pPr algn="ctr"/>
+            <a:r>
+              <a:rPr lang="en-US" sz="900" dirty="0" err="1">
+                <a:solidFill>
+                  <a:srgbClr val="7030A0"/>
+                </a:solidFill>
+              </a:rPr>
+              <a:t>id_ex_alu_op</a:t>
+            </a:r>
+            <a:endParaRPr lang="en-US" sz="900" dirty="0">
+              <a:solidFill>
+                <a:srgbClr val="7030A0"/>
+              </a:solidFill>
+            </a:endParaRPr>
+          </a:p>
+        </p:txBody>
+      </p:sp>
+      <p:sp>
+        <p:nvSpPr>
+          <p:cNvPr id="327" name="TextBox 326">
+            <a:extLst>
+              <a:ext uri="{FF2B5EF4-FFF2-40B4-BE49-F238E27FC236}">
+                <a16:creationId xmlns:a16="http://schemas.microsoft.com/office/drawing/2014/main" id="{711682A3-5E3F-0208-5E12-FBCDEF285FFA}"/>
+              </a:ext>
+            </a:extLst>
+          </p:cNvPr>
+          <p:cNvSpPr txBox="1"/>
+          <p:nvPr/>
+        </p:nvSpPr>
+        <p:spPr>
+          <a:xfrm>
+            <a:off x="5989961" y="2205179"/>
+            <a:ext cx="1226619" cy="230832"/>
+          </a:xfrm>
+          <a:prstGeom prst="rect">
+            <a:avLst/>
+          </a:prstGeom>
+          <a:noFill/>
+        </p:spPr>
+        <p:txBody>
+          <a:bodyPr wrap="none" rtlCol="0">
+            <a:spAutoFit/>
+          </a:bodyPr>
+          <a:lstStyle/>
+          <a:p>
+            <a:pPr algn="ctr"/>
+            <a:r>
+              <a:rPr lang="en-US" sz="900" dirty="0" err="1">
+                <a:solidFill>
+                  <a:srgbClr val="7030A0"/>
+                </a:solidFill>
+              </a:rPr>
+              <a:t>mem_wb_mem_data</a:t>
+            </a:r>
+            <a:endParaRPr lang="en-US" sz="900" dirty="0">
+              <a:solidFill>
+                <a:srgbClr val="7030A0"/>
+              </a:solidFill>
+            </a:endParaRPr>
+          </a:p>
+        </p:txBody>
+      </p:sp>
+      <p:sp>
+        <p:nvSpPr>
+          <p:cNvPr id="328" name="TextBox 327">
+            <a:extLst>
+              <a:ext uri="{FF2B5EF4-FFF2-40B4-BE49-F238E27FC236}">
+                <a16:creationId xmlns:a16="http://schemas.microsoft.com/office/drawing/2014/main" id="{5F71F902-0DA3-35A1-4DF8-C7541F00D91E}"/>
+              </a:ext>
+            </a:extLst>
+          </p:cNvPr>
+          <p:cNvSpPr txBox="1"/>
+          <p:nvPr/>
+        </p:nvSpPr>
+        <p:spPr>
+          <a:xfrm>
+            <a:off x="6547604" y="5603754"/>
+            <a:ext cx="877163" cy="230832"/>
+          </a:xfrm>
+          <a:prstGeom prst="rect">
+            <a:avLst/>
+          </a:prstGeom>
+          <a:noFill/>
+        </p:spPr>
+        <p:txBody>
+          <a:bodyPr wrap="none" rtlCol="0">
+            <a:spAutoFit/>
+          </a:bodyPr>
+          <a:lstStyle/>
+          <a:p>
+            <a:pPr algn="ctr"/>
+            <a:r>
+              <a:rPr lang="en-US" sz="900" dirty="0" err="1">
+                <a:solidFill>
+                  <a:srgbClr val="7030A0"/>
+                </a:solidFill>
+              </a:rPr>
+              <a:t>mux_select_A</a:t>
+            </a:r>
+            <a:endParaRPr lang="en-US" sz="900" dirty="0">
+              <a:solidFill>
+                <a:srgbClr val="7030A0"/>
+              </a:solidFill>
+            </a:endParaRPr>
+          </a:p>
+        </p:txBody>
+      </p:sp>
+      <p:cxnSp>
+        <p:nvCxnSpPr>
+          <p:cNvPr id="332" name="Straight Connector 331">
+            <a:extLst>
+              <a:ext uri="{FF2B5EF4-FFF2-40B4-BE49-F238E27FC236}">
+                <a16:creationId xmlns:a16="http://schemas.microsoft.com/office/drawing/2014/main" id="{25FC4C7B-6FAC-08E2-DE50-24FBE9C8E965}"/>
+              </a:ext>
+            </a:extLst>
+          </p:cNvPr>
+          <p:cNvCxnSpPr>
+            <a:cxnSpLocks/>
+          </p:cNvCxnSpPr>
+          <p:nvPr/>
+        </p:nvCxnSpPr>
+        <p:spPr>
+          <a:xfrm flipH="1">
+            <a:off x="6895136" y="5022889"/>
+            <a:ext cx="260576" cy="0"/>
+          </a:xfrm>
+          <a:prstGeom prst="line">
+            <a:avLst/>
+          </a:prstGeom>
+          <a:ln>
+            <a:solidFill>
+              <a:srgbClr val="7030A0"/>
+            </a:solidFill>
+          </a:ln>
+        </p:spPr>
+        <p:style>
+          <a:lnRef idx="2">
+            <a:schemeClr val="accent1"/>
+          </a:lnRef>
+          <a:fillRef idx="0">
+            <a:schemeClr val="accent1"/>
+          </a:fillRef>
+          <a:effectRef idx="1">
+            <a:schemeClr val="accent1"/>
+          </a:effectRef>
+          <a:fontRef idx="minor">
+            <a:schemeClr val="tx1"/>
+          </a:fontRef>
+        </p:style>
+      </p:cxnSp>
+      <p:sp>
+        <p:nvSpPr>
+          <p:cNvPr id="335" name="TextBox 334">
+            <a:extLst>
+              <a:ext uri="{FF2B5EF4-FFF2-40B4-BE49-F238E27FC236}">
+                <a16:creationId xmlns:a16="http://schemas.microsoft.com/office/drawing/2014/main" id="{3CA03AE4-7E89-60FC-7612-2C4BD4408B15}"/>
+              </a:ext>
+            </a:extLst>
+          </p:cNvPr>
+          <p:cNvSpPr txBox="1"/>
+          <p:nvPr/>
+        </p:nvSpPr>
+        <p:spPr>
+          <a:xfrm>
+            <a:off x="6046095" y="2416998"/>
+            <a:ext cx="1154483" cy="230832"/>
+          </a:xfrm>
+          <a:prstGeom prst="rect">
+            <a:avLst/>
+          </a:prstGeom>
+          <a:noFill/>
+        </p:spPr>
+        <p:txBody>
+          <a:bodyPr wrap="none" rtlCol="0">
+            <a:spAutoFit/>
+          </a:bodyPr>
+          <a:lstStyle/>
+          <a:p>
+            <a:pPr algn="ctr"/>
+            <a:r>
+              <a:rPr lang="en-US" sz="900" dirty="0" err="1">
+                <a:solidFill>
+                  <a:srgbClr val="7030A0"/>
+                </a:solidFill>
+              </a:rPr>
+              <a:t>ex_mem_alu_result</a:t>
+            </a:r>
+            <a:endParaRPr lang="en-US" sz="900" dirty="0">
+              <a:solidFill>
+                <a:srgbClr val="7030A0"/>
+              </a:solidFill>
+            </a:endParaRPr>
+          </a:p>
+        </p:txBody>
+      </p:sp>
+      <p:sp>
+        <p:nvSpPr>
+          <p:cNvPr id="336" name="TextBox 335">
+            <a:extLst>
+              <a:ext uri="{FF2B5EF4-FFF2-40B4-BE49-F238E27FC236}">
+                <a16:creationId xmlns:a16="http://schemas.microsoft.com/office/drawing/2014/main" id="{6E885DD7-3EDD-E771-917F-CA86F4308FA3}"/>
+              </a:ext>
+            </a:extLst>
+          </p:cNvPr>
+          <p:cNvSpPr txBox="1"/>
+          <p:nvPr/>
+        </p:nvSpPr>
+        <p:spPr>
+          <a:xfrm>
+            <a:off x="4401834" y="3369974"/>
+            <a:ext cx="989373" cy="230832"/>
+          </a:xfrm>
+          <a:prstGeom prst="rect">
+            <a:avLst/>
+          </a:prstGeom>
+          <a:noFill/>
+        </p:spPr>
+        <p:txBody>
+          <a:bodyPr wrap="none" rtlCol="0">
+            <a:spAutoFit/>
+          </a:bodyPr>
+          <a:lstStyle/>
+          <a:p>
+            <a:pPr algn="ctr"/>
+            <a:r>
+              <a:rPr lang="en-US" sz="900" dirty="0">
+                <a:solidFill>
+                  <a:srgbClr val="7030A0"/>
+                </a:solidFill>
+              </a:rPr>
+              <a:t>id_ex_reg1_data</a:t>
+            </a:r>
+          </a:p>
+        </p:txBody>
+      </p:sp>
+      <p:cxnSp>
+        <p:nvCxnSpPr>
+          <p:cNvPr id="337" name="Straight Connector 336">
+            <a:extLst>
+              <a:ext uri="{FF2B5EF4-FFF2-40B4-BE49-F238E27FC236}">
+                <a16:creationId xmlns:a16="http://schemas.microsoft.com/office/drawing/2014/main" id="{139619B3-BE80-4134-8CE5-41B639CB7104}"/>
+              </a:ext>
+            </a:extLst>
+          </p:cNvPr>
+          <p:cNvCxnSpPr>
+            <a:cxnSpLocks/>
+          </p:cNvCxnSpPr>
+          <p:nvPr/>
+        </p:nvCxnSpPr>
+        <p:spPr>
+          <a:xfrm flipH="1">
+            <a:off x="7611643" y="3654052"/>
+            <a:ext cx="1245278" cy="1791"/>
+          </a:xfrm>
+          <a:prstGeom prst="line">
+            <a:avLst/>
+          </a:prstGeom>
+          <a:ln>
+            <a:solidFill>
+              <a:srgbClr val="7030A0"/>
+            </a:solidFill>
+          </a:ln>
+        </p:spPr>
+        <p:style>
+          <a:lnRef idx="2">
+            <a:schemeClr val="accent1"/>
+          </a:lnRef>
+          <a:fillRef idx="0">
+            <a:schemeClr val="accent1"/>
+          </a:fillRef>
+          <a:effectRef idx="1">
+            <a:schemeClr val="accent1"/>
+          </a:effectRef>
+          <a:fontRef idx="minor">
+            <a:schemeClr val="tx1"/>
+          </a:fontRef>
+        </p:style>
+      </p:cxnSp>
+      <p:cxnSp>
+        <p:nvCxnSpPr>
+          <p:cNvPr id="345" name="Straight Connector 344">
+            <a:extLst>
+              <a:ext uri="{FF2B5EF4-FFF2-40B4-BE49-F238E27FC236}">
+                <a16:creationId xmlns:a16="http://schemas.microsoft.com/office/drawing/2014/main" id="{5E6AD3B2-3C2A-4E45-CE3A-0CE068357472}"/>
+              </a:ext>
+            </a:extLst>
+          </p:cNvPr>
+          <p:cNvCxnSpPr>
+            <a:cxnSpLocks/>
+          </p:cNvCxnSpPr>
+          <p:nvPr/>
+        </p:nvCxnSpPr>
+        <p:spPr>
+          <a:xfrm flipH="1">
+            <a:off x="7609289" y="3486482"/>
+            <a:ext cx="1050630" cy="0"/>
+          </a:xfrm>
+          <a:prstGeom prst="line">
+            <a:avLst/>
+          </a:prstGeom>
+          <a:ln>
+            <a:solidFill>
+              <a:srgbClr val="7030A0"/>
+            </a:solidFill>
+          </a:ln>
+        </p:spPr>
+        <p:style>
+          <a:lnRef idx="2">
+            <a:schemeClr val="accent1"/>
+          </a:lnRef>
+          <a:fillRef idx="0">
+            <a:schemeClr val="accent1"/>
+          </a:fillRef>
+          <a:effectRef idx="1">
+            <a:schemeClr val="accent1"/>
+          </a:effectRef>
+          <a:fontRef idx="minor">
+            <a:schemeClr val="tx1"/>
+          </a:fontRef>
+        </p:style>
+      </p:cxnSp>
+      <p:sp>
+        <p:nvSpPr>
+          <p:cNvPr id="351" name="TextBox 350">
+            <a:extLst>
+              <a:ext uri="{FF2B5EF4-FFF2-40B4-BE49-F238E27FC236}">
+                <a16:creationId xmlns:a16="http://schemas.microsoft.com/office/drawing/2014/main" id="{6B2A40BA-AFCB-0F51-613A-8F30B4ED9C8D}"/>
+              </a:ext>
+            </a:extLst>
+          </p:cNvPr>
+          <p:cNvSpPr txBox="1"/>
+          <p:nvPr/>
+        </p:nvSpPr>
+        <p:spPr>
+          <a:xfrm>
+            <a:off x="7515464" y="3301900"/>
+            <a:ext cx="1192955" cy="230832"/>
+          </a:xfrm>
+          <a:prstGeom prst="rect">
+            <a:avLst/>
+          </a:prstGeom>
+          <a:noFill/>
+        </p:spPr>
+        <p:txBody>
+          <a:bodyPr wrap="none" rtlCol="0">
+            <a:spAutoFit/>
+          </a:bodyPr>
+          <a:lstStyle/>
+          <a:p>
+            <a:pPr algn="ctr"/>
+            <a:r>
+              <a:rPr lang="en-US" sz="900" dirty="0" err="1">
+                <a:solidFill>
+                  <a:srgbClr val="7030A0"/>
+                </a:solidFill>
+              </a:rPr>
+              <a:t>ex_mem_mem_read</a:t>
+            </a:r>
+            <a:endParaRPr lang="en-US" sz="900" dirty="0">
+              <a:solidFill>
+                <a:srgbClr val="7030A0"/>
+              </a:solidFill>
+            </a:endParaRPr>
+          </a:p>
+        </p:txBody>
+      </p:sp>
+      <p:sp>
+        <p:nvSpPr>
+          <p:cNvPr id="145" name="TextBox 144">
+            <a:extLst>
+              <a:ext uri="{FF2B5EF4-FFF2-40B4-BE49-F238E27FC236}">
+                <a16:creationId xmlns:a16="http://schemas.microsoft.com/office/drawing/2014/main" id="{B2E368A6-EAC0-5B64-D59C-9045C5BF7D0E}"/>
+              </a:ext>
+            </a:extLst>
+          </p:cNvPr>
+          <p:cNvSpPr txBox="1"/>
+          <p:nvPr/>
+        </p:nvSpPr>
+        <p:spPr>
+          <a:xfrm>
+            <a:off x="7614905" y="3480342"/>
+            <a:ext cx="1215397" cy="230832"/>
+          </a:xfrm>
+          <a:prstGeom prst="rect">
+            <a:avLst/>
+          </a:prstGeom>
+          <a:noFill/>
+        </p:spPr>
+        <p:txBody>
+          <a:bodyPr wrap="none" rtlCol="0">
+            <a:spAutoFit/>
+          </a:bodyPr>
+          <a:lstStyle/>
+          <a:p>
+            <a:pPr algn="ctr"/>
+            <a:r>
+              <a:rPr lang="en-US" sz="900" dirty="0" err="1">
+                <a:solidFill>
+                  <a:srgbClr val="7030A0"/>
+                </a:solidFill>
+              </a:rPr>
+              <a:t>ex_mem_mem_write</a:t>
+            </a:r>
+            <a:endParaRPr lang="en-US" sz="900" dirty="0">
+              <a:solidFill>
+                <a:srgbClr val="7030A0"/>
+              </a:solidFill>
+            </a:endParaRPr>
+          </a:p>
+        </p:txBody>
+      </p:sp>
+      <p:cxnSp>
+        <p:nvCxnSpPr>
+          <p:cNvPr id="175" name="Straight Connector 174">
+            <a:extLst>
+              <a:ext uri="{FF2B5EF4-FFF2-40B4-BE49-F238E27FC236}">
+                <a16:creationId xmlns:a16="http://schemas.microsoft.com/office/drawing/2014/main" id="{709F9C77-5C7A-9691-4F66-16B3DBABF430}"/>
+              </a:ext>
+            </a:extLst>
+          </p:cNvPr>
+          <p:cNvCxnSpPr>
+            <a:cxnSpLocks/>
+          </p:cNvCxnSpPr>
+          <p:nvPr/>
+        </p:nvCxnSpPr>
+        <p:spPr>
+          <a:xfrm flipH="1">
+            <a:off x="10130870" y="4687358"/>
+            <a:ext cx="1188005" cy="0"/>
+          </a:xfrm>
+          <a:prstGeom prst="line">
+            <a:avLst/>
+          </a:prstGeom>
+          <a:ln>
+            <a:solidFill>
+              <a:srgbClr val="7030A0"/>
+            </a:solidFill>
+          </a:ln>
+        </p:spPr>
+        <p:style>
+          <a:lnRef idx="2">
+            <a:schemeClr val="accent1"/>
+          </a:lnRef>
+          <a:fillRef idx="0">
+            <a:schemeClr val="accent1"/>
+          </a:fillRef>
+          <a:effectRef idx="1">
+            <a:schemeClr val="accent1"/>
+          </a:effectRef>
+          <a:fontRef idx="minor">
+            <a:schemeClr val="tx1"/>
+          </a:fontRef>
+        </p:style>
+      </p:cxnSp>
+      <p:cxnSp>
+        <p:nvCxnSpPr>
+          <p:cNvPr id="176" name="Straight Connector 175">
+            <a:extLst>
+              <a:ext uri="{FF2B5EF4-FFF2-40B4-BE49-F238E27FC236}">
+                <a16:creationId xmlns:a16="http://schemas.microsoft.com/office/drawing/2014/main" id="{900E5A65-7A8F-9A67-1B56-9B205D1512F2}"/>
+              </a:ext>
+            </a:extLst>
+          </p:cNvPr>
+          <p:cNvCxnSpPr>
+            <a:cxnSpLocks/>
+          </p:cNvCxnSpPr>
+          <p:nvPr/>
+        </p:nvCxnSpPr>
+        <p:spPr>
+          <a:xfrm flipH="1" flipV="1">
+            <a:off x="10137220" y="4961621"/>
+            <a:ext cx="1188005" cy="7239"/>
+          </a:xfrm>
+          <a:prstGeom prst="line">
+            <a:avLst/>
+          </a:prstGeom>
+          <a:ln>
+            <a:solidFill>
+              <a:srgbClr val="7030A0"/>
+            </a:solidFill>
+          </a:ln>
+        </p:spPr>
+        <p:style>
+          <a:lnRef idx="2">
+            <a:schemeClr val="accent1"/>
+          </a:lnRef>
+          <a:fillRef idx="0">
+            <a:schemeClr val="accent1"/>
+          </a:fillRef>
+          <a:effectRef idx="1">
+            <a:schemeClr val="accent1"/>
+          </a:effectRef>
+          <a:fontRef idx="minor">
+            <a:schemeClr val="tx1"/>
+          </a:fontRef>
+        </p:style>
+      </p:cxnSp>
+      <p:sp>
+        <p:nvSpPr>
+          <p:cNvPr id="177" name="TextBox 176">
+            <a:extLst>
+              <a:ext uri="{FF2B5EF4-FFF2-40B4-BE49-F238E27FC236}">
+                <a16:creationId xmlns:a16="http://schemas.microsoft.com/office/drawing/2014/main" id="{2B0BC105-E4B5-56B5-3E5B-B6D22A84A939}"/>
+              </a:ext>
+            </a:extLst>
+          </p:cNvPr>
+          <p:cNvSpPr txBox="1"/>
+          <p:nvPr/>
+        </p:nvSpPr>
+        <p:spPr>
+          <a:xfrm>
+            <a:off x="10084244" y="4227555"/>
+            <a:ext cx="1228221" cy="230832"/>
+          </a:xfrm>
+          <a:prstGeom prst="rect">
+            <a:avLst/>
+          </a:prstGeom>
+          <a:noFill/>
+        </p:spPr>
+        <p:txBody>
+          <a:bodyPr wrap="none" rtlCol="0">
+            <a:spAutoFit/>
+          </a:bodyPr>
+          <a:lstStyle/>
+          <a:p>
+            <a:pPr algn="ctr"/>
+            <a:r>
+              <a:rPr lang="en-US" sz="900" dirty="0" err="1">
+                <a:solidFill>
+                  <a:srgbClr val="7030A0"/>
+                </a:solidFill>
+              </a:rPr>
+              <a:t>mem_wb_mem_read</a:t>
+            </a:r>
+            <a:endParaRPr lang="en-US" sz="900" dirty="0">
+              <a:solidFill>
+                <a:srgbClr val="7030A0"/>
+              </a:solidFill>
+            </a:endParaRPr>
+          </a:p>
+        </p:txBody>
+      </p:sp>
+      <p:sp>
+        <p:nvSpPr>
+          <p:cNvPr id="181" name="TextBox 180">
+            <a:extLst>
+              <a:ext uri="{FF2B5EF4-FFF2-40B4-BE49-F238E27FC236}">
+                <a16:creationId xmlns:a16="http://schemas.microsoft.com/office/drawing/2014/main" id="{8E945B2E-40BF-34A4-B962-70F4F17AC4C9}"/>
+              </a:ext>
+            </a:extLst>
+          </p:cNvPr>
+          <p:cNvSpPr txBox="1"/>
+          <p:nvPr/>
+        </p:nvSpPr>
+        <p:spPr>
+          <a:xfrm>
+            <a:off x="10094723" y="4494552"/>
+            <a:ext cx="1250663" cy="230832"/>
+          </a:xfrm>
+          <a:prstGeom prst="rect">
+            <a:avLst/>
+          </a:prstGeom>
+          <a:noFill/>
+        </p:spPr>
+        <p:txBody>
+          <a:bodyPr wrap="none" rtlCol="0">
+            <a:spAutoFit/>
+          </a:bodyPr>
+          <a:lstStyle/>
+          <a:p>
+            <a:pPr algn="ctr"/>
+            <a:r>
+              <a:rPr lang="en-US" sz="900" dirty="0" err="1">
+                <a:solidFill>
+                  <a:srgbClr val="7030A0"/>
+                </a:solidFill>
+              </a:rPr>
+              <a:t>mem_wb_mem_write</a:t>
+            </a:r>
+            <a:endParaRPr lang="en-US" sz="900" dirty="0">
+              <a:solidFill>
+                <a:srgbClr val="7030A0"/>
+              </a:solidFill>
+            </a:endParaRPr>
+          </a:p>
+        </p:txBody>
+      </p:sp>
+      <p:sp>
+        <p:nvSpPr>
+          <p:cNvPr id="182" name="TextBox 181">
+            <a:extLst>
+              <a:ext uri="{FF2B5EF4-FFF2-40B4-BE49-F238E27FC236}">
+                <a16:creationId xmlns:a16="http://schemas.microsoft.com/office/drawing/2014/main" id="{5B75298E-DCD3-10FA-21AB-DA49FAFBACD3}"/>
+              </a:ext>
+            </a:extLst>
+          </p:cNvPr>
+          <p:cNvSpPr txBox="1"/>
+          <p:nvPr/>
+        </p:nvSpPr>
+        <p:spPr>
+          <a:xfrm>
+            <a:off x="10125773" y="4792057"/>
+            <a:ext cx="1194558" cy="230832"/>
+          </a:xfrm>
+          <a:prstGeom prst="rect">
+            <a:avLst/>
+          </a:prstGeom>
+          <a:noFill/>
+        </p:spPr>
+        <p:txBody>
+          <a:bodyPr wrap="none" rtlCol="0">
+            <a:spAutoFit/>
+          </a:bodyPr>
+          <a:lstStyle/>
+          <a:p>
+            <a:pPr algn="ctr"/>
+            <a:r>
+              <a:rPr lang="en-US" sz="900" dirty="0" err="1">
+                <a:solidFill>
+                  <a:srgbClr val="7030A0"/>
+                </a:solidFill>
+              </a:rPr>
+              <a:t>mem_wb_load_addr</a:t>
+            </a:r>
+            <a:endParaRPr lang="en-US" sz="900" dirty="0">
+              <a:solidFill>
+                <a:srgbClr val="7030A0"/>
+              </a:solidFill>
+            </a:endParaRPr>
+          </a:p>
+        </p:txBody>
+      </p:sp>
+      <p:cxnSp>
+        <p:nvCxnSpPr>
+          <p:cNvPr id="185" name="Straight Connector 184">
+            <a:extLst>
+              <a:ext uri="{FF2B5EF4-FFF2-40B4-BE49-F238E27FC236}">
+                <a16:creationId xmlns:a16="http://schemas.microsoft.com/office/drawing/2014/main" id="{81C51850-C079-1DDB-59F4-6E809237D94D}"/>
+              </a:ext>
+            </a:extLst>
+          </p:cNvPr>
+          <p:cNvCxnSpPr>
+            <a:cxnSpLocks/>
+          </p:cNvCxnSpPr>
+          <p:nvPr/>
+        </p:nvCxnSpPr>
+        <p:spPr>
+          <a:xfrm flipH="1">
+            <a:off x="10969389" y="4198572"/>
+            <a:ext cx="371711" cy="0"/>
+          </a:xfrm>
+          <a:prstGeom prst="line">
+            <a:avLst/>
+          </a:prstGeom>
+          <a:ln>
+            <a:solidFill>
+              <a:srgbClr val="7030A0"/>
+            </a:solidFill>
+          </a:ln>
+        </p:spPr>
+        <p:style>
+          <a:lnRef idx="2">
+            <a:schemeClr val="accent1"/>
+          </a:lnRef>
+          <a:fillRef idx="0">
+            <a:schemeClr val="accent1"/>
+          </a:fillRef>
+          <a:effectRef idx="1">
+            <a:schemeClr val="accent1"/>
+          </a:effectRef>
+          <a:fontRef idx="minor">
+            <a:schemeClr val="tx1"/>
+          </a:fontRef>
+        </p:style>
+      </p:cxnSp>
+      <p:cxnSp>
+        <p:nvCxnSpPr>
+          <p:cNvPr id="201" name="Straight Connector 200">
+            <a:extLst>
+              <a:ext uri="{FF2B5EF4-FFF2-40B4-BE49-F238E27FC236}">
+                <a16:creationId xmlns:a16="http://schemas.microsoft.com/office/drawing/2014/main" id="{9B334E6D-A528-847B-9B08-88ACD6D1066C}"/>
+              </a:ext>
+            </a:extLst>
+          </p:cNvPr>
+          <p:cNvCxnSpPr>
+            <a:cxnSpLocks/>
+          </p:cNvCxnSpPr>
+          <p:nvPr/>
+        </p:nvCxnSpPr>
+        <p:spPr>
+          <a:xfrm>
+            <a:off x="11328400" y="4203700"/>
+            <a:ext cx="0" cy="757921"/>
+          </a:xfrm>
+          <a:prstGeom prst="line">
+            <a:avLst/>
+          </a:prstGeom>
+          <a:ln>
+            <a:solidFill>
+              <a:srgbClr val="7030A0"/>
+            </a:solidFill>
+          </a:ln>
+        </p:spPr>
+        <p:style>
+          <a:lnRef idx="2">
+            <a:schemeClr val="accent1"/>
+          </a:lnRef>
+          <a:fillRef idx="0">
+            <a:schemeClr val="accent1"/>
+          </a:fillRef>
+          <a:effectRef idx="1">
+            <a:schemeClr val="accent1"/>
+          </a:effectRef>
+          <a:fontRef idx="minor">
+            <a:schemeClr val="tx1"/>
+          </a:fontRef>
+        </p:style>
+      </p:cxnSp>
     </p:spTree>
     <p:extLst>
       <p:ext uri="{BB962C8B-B14F-4D97-AF65-F5344CB8AC3E}">

</xml_diff>